<commit_message>
Polish TA data flow diagram and specify data-flow categories in hub
- Added subtle drop shadows to every front/middle/back-office box for
  visual depth, and bolder straight connector lines (1.5pt -> 1.75pt).
- Replaced the center hub's generic "core TA functions" bullets with an
  explicit "Data in Transit" list naming the six data categories that
  actually move through the hub: Orders, Cash, Customer Info, Tax Info,
  Dividends, and Holdings — each with its own icon.

Co-Authored-By: Claude Sonnet 5 <noreply@anthropic.com>
Claude-Session: https://claude.ai/code/session_01XLt1ze3JWdaihuSAsk6TrZ
</commit_message>
<xml_diff>
--- a/docs/presentations/Transfer_Agent_Data_Flow.pptx
+++ b/docs/presentations/Transfer_Agent_Data_Flow.pptx
@@ -1707,8 +1707,8 @@
         </p:nvSpPr>
         <p:spPr>
           <a:xfrm>
-            <a:off x="4416552" y="3392424"/>
-            <a:ext cx="1691640" cy="2514600"/>
+            <a:off x="4297680" y="3337560"/>
+            <a:ext cx="1874520" cy="219456"/>
           </a:xfrm>
           <a:prstGeom prst="rect">
             <a:avLst/>
@@ -1717,21 +1717,97 @@
           <a:ln/>
         </p:spPr>
         <p:txBody>
-          <a:bodyPr wrap="square" lIns="0" tIns="0" rIns="0" bIns="0" rtlCol="0" anchor="t"/>
+          <a:bodyPr wrap="square" lIns="0" tIns="0" rIns="0" bIns="0" rtlCol="0" anchor="ctr"/>
           <a:lstStyle/>
           <a:p>
-            <a:pPr algn="l" marL="342900" indent="-342900">
-              <a:lnSpc>
-                <a:spcPct val="130000"/>
-              </a:lnSpc>
-              <a:spcAft>
-                <a:spcPts val="900"/>
-              </a:spcAft>
-              <a:buSzPct val="100000"/>
-              <a:buChar char="•"/>
+            <a:pPr algn="ctr" indent="0" marL="0">
+              <a:buNone/>
             </a:pPr>
             <a:r>
-              <a:rPr lang="en-US" sz="1050" dirty="0">
+              <a:rPr lang="en-US" sz="900" b="1" spc="150" kern="0" dirty="0">
+                <a:solidFill>
+                  <a:srgbClr val="8891B3"/>
+                </a:solidFill>
+                <a:latin typeface="Calibri" pitchFamily="34" charset="0"/>
+                <a:ea typeface="Calibri" pitchFamily="34" charset="-122"/>
+                <a:cs typeface="Calibri" pitchFamily="34" charset="-120"/>
+              </a:rPr>
+              <a:t>DATA IN TRANSIT</a:t>
+            </a:r>
+            <a:endParaRPr lang="en-US" sz="900" dirty="0"/>
+          </a:p>
+        </p:txBody>
+      </p:sp>
+      <p:sp>
+        <p:nvSpPr>
+          <p:cNvPr id="17" name="Shape 14"/>
+          <p:cNvSpPr/>
+          <p:nvPr/>
+        </p:nvSpPr>
+        <p:spPr>
+          <a:xfrm>
+            <a:off x="4361688" y="3680460"/>
+            <a:ext cx="274320" cy="274320"/>
+          </a:xfrm>
+          <a:prstGeom prst="ellipse">
+            <a:avLst/>
+          </a:prstGeom>
+          <a:solidFill>
+            <a:srgbClr val="3A4694"/>
+          </a:solidFill>
+          <a:ln/>
+        </p:spPr>
+      </p:sp>
+      <p:pic>
+        <p:nvPicPr>
+          <p:cNvPr id="18" name="Image 1" descr="preencoded.png">    </p:cNvPr>
+          <p:cNvPicPr>
+            <a:picLocks noChangeAspect="1"/>
+          </p:cNvPicPr>
+          <p:nvPr/>
+        </p:nvPicPr>
+        <p:blipFill>
+          <a:blip r:embed="rId2"/>
+          <a:stretch>
+            <a:fillRect/>
+          </a:stretch>
+        </p:blipFill>
+        <p:spPr>
+          <a:xfrm>
+            <a:off x="4433011" y="3751783"/>
+            <a:ext cx="131674" cy="131674"/>
+          </a:xfrm>
+          <a:prstGeom prst="rect">
+            <a:avLst/>
+          </a:prstGeom>
+        </p:spPr>
+      </p:pic>
+      <p:sp>
+        <p:nvSpPr>
+          <p:cNvPr id="19" name="Text 15"/>
+          <p:cNvSpPr txBox="1"/>
+          <p:nvPr/>
+        </p:nvSpPr>
+        <p:spPr>
+          <a:xfrm>
+            <a:off x="4764024" y="3648456"/>
+            <a:ext cx="1408176" cy="338328"/>
+          </a:xfrm>
+          <a:prstGeom prst="rect">
+            <a:avLst/>
+          </a:prstGeom>
+          <a:noFill/>
+          <a:ln/>
+        </p:spPr>
+        <p:txBody>
+          <a:bodyPr wrap="square" lIns="0" tIns="0" rIns="0" bIns="0" rtlCol="0" anchor="ctr"/>
+          <a:lstStyle/>
+          <a:p>
+            <a:pPr algn="l" indent="0" marL="0">
+              <a:buNone/>
+            </a:pPr>
+            <a:r>
+              <a:rPr lang="en-US" sz="1150" b="1" dirty="0">
                 <a:solidFill>
                   <a:srgbClr val="CADCFC"/>
                 </a:solidFill>
@@ -1739,23 +1815,82 @@
                 <a:ea typeface="Calibri" pitchFamily="34" charset="-122"/>
                 <a:cs typeface="Calibri" pitchFamily="34" charset="-120"/>
               </a:rPr>
-              <a:t>Order processing &amp; NAV application</a:t>
-            </a:r>
-            <a:endParaRPr lang="en-US" sz="1050" dirty="0"/>
-          </a:p>
-          <a:p>
-            <a:pPr algn="l" marL="342900" indent="-342900">
-              <a:lnSpc>
-                <a:spcPct val="130000"/>
-              </a:lnSpc>
-              <a:spcAft>
-                <a:spcPts val="900"/>
-              </a:spcAft>
-              <a:buSzPct val="100000"/>
-              <a:buChar char="•"/>
+              <a:t>Orders</a:t>
+            </a:r>
+            <a:endParaRPr lang="en-US" sz="1150" dirty="0"/>
+          </a:p>
+        </p:txBody>
+      </p:sp>
+      <p:sp>
+        <p:nvSpPr>
+          <p:cNvPr id="20" name="Shape 16"/>
+          <p:cNvSpPr/>
+          <p:nvPr/>
+        </p:nvSpPr>
+        <p:spPr>
+          <a:xfrm>
+            <a:off x="4361688" y="4055364"/>
+            <a:ext cx="274320" cy="274320"/>
+          </a:xfrm>
+          <a:prstGeom prst="ellipse">
+            <a:avLst/>
+          </a:prstGeom>
+          <a:solidFill>
+            <a:srgbClr val="3A4694"/>
+          </a:solidFill>
+          <a:ln/>
+        </p:spPr>
+      </p:sp>
+      <p:pic>
+        <p:nvPicPr>
+          <p:cNvPr id="21" name="Image 2" descr="preencoded.png">    </p:cNvPr>
+          <p:cNvPicPr>
+            <a:picLocks noChangeAspect="1"/>
+          </p:cNvPicPr>
+          <p:nvPr/>
+        </p:nvPicPr>
+        <p:blipFill>
+          <a:blip r:embed="rId3"/>
+          <a:stretch>
+            <a:fillRect/>
+          </a:stretch>
+        </p:blipFill>
+        <p:spPr>
+          <a:xfrm>
+            <a:off x="4433011" y="4126687"/>
+            <a:ext cx="131674" cy="131674"/>
+          </a:xfrm>
+          <a:prstGeom prst="rect">
+            <a:avLst/>
+          </a:prstGeom>
+        </p:spPr>
+      </p:pic>
+      <p:sp>
+        <p:nvSpPr>
+          <p:cNvPr id="22" name="Text 17"/>
+          <p:cNvSpPr txBox="1"/>
+          <p:nvPr/>
+        </p:nvSpPr>
+        <p:spPr>
+          <a:xfrm>
+            <a:off x="4764024" y="4023360"/>
+            <a:ext cx="1408176" cy="338328"/>
+          </a:xfrm>
+          <a:prstGeom prst="rect">
+            <a:avLst/>
+          </a:prstGeom>
+          <a:noFill/>
+          <a:ln/>
+        </p:spPr>
+        <p:txBody>
+          <a:bodyPr wrap="square" lIns="0" tIns="0" rIns="0" bIns="0" rtlCol="0" anchor="ctr"/>
+          <a:lstStyle/>
+          <a:p>
+            <a:pPr algn="l" indent="0" marL="0">
+              <a:buNone/>
             </a:pPr>
             <a:r>
-              <a:rPr lang="en-US" sz="1050" dirty="0">
+              <a:rPr lang="en-US" sz="1150" b="1" dirty="0">
                 <a:solidFill>
                   <a:srgbClr val="CADCFC"/>
                 </a:solidFill>
@@ -1763,23 +1898,82 @@
                 <a:ea typeface="Calibri" pitchFamily="34" charset="-122"/>
                 <a:cs typeface="Calibri" pitchFamily="34" charset="-120"/>
               </a:rPr>
-              <a:t>Master securityholder file</a:t>
-            </a:r>
-            <a:endParaRPr lang="en-US" sz="1050" dirty="0"/>
-          </a:p>
-          <a:p>
-            <a:pPr algn="l" marL="342900" indent="-342900">
-              <a:lnSpc>
-                <a:spcPct val="130000"/>
-              </a:lnSpc>
-              <a:spcAft>
-                <a:spcPts val="900"/>
-              </a:spcAft>
-              <a:buSzPct val="100000"/>
-              <a:buChar char="•"/>
+              <a:t>Cash</a:t>
+            </a:r>
+            <a:endParaRPr lang="en-US" sz="1150" dirty="0"/>
+          </a:p>
+        </p:txBody>
+      </p:sp>
+      <p:sp>
+        <p:nvSpPr>
+          <p:cNvPr id="23" name="Shape 18"/>
+          <p:cNvSpPr/>
+          <p:nvPr/>
+        </p:nvSpPr>
+        <p:spPr>
+          <a:xfrm>
+            <a:off x="4361688" y="4430268"/>
+            <a:ext cx="274320" cy="274320"/>
+          </a:xfrm>
+          <a:prstGeom prst="ellipse">
+            <a:avLst/>
+          </a:prstGeom>
+          <a:solidFill>
+            <a:srgbClr val="3A4694"/>
+          </a:solidFill>
+          <a:ln/>
+        </p:spPr>
+      </p:sp>
+      <p:pic>
+        <p:nvPicPr>
+          <p:cNvPr id="24" name="Image 3" descr="preencoded.png">    </p:cNvPr>
+          <p:cNvPicPr>
+            <a:picLocks noChangeAspect="1"/>
+          </p:cNvPicPr>
+          <p:nvPr/>
+        </p:nvPicPr>
+        <p:blipFill>
+          <a:blip r:embed="rId4"/>
+          <a:stretch>
+            <a:fillRect/>
+          </a:stretch>
+        </p:blipFill>
+        <p:spPr>
+          <a:xfrm>
+            <a:off x="4433011" y="4501591"/>
+            <a:ext cx="131674" cy="131674"/>
+          </a:xfrm>
+          <a:prstGeom prst="rect">
+            <a:avLst/>
+          </a:prstGeom>
+        </p:spPr>
+      </p:pic>
+      <p:sp>
+        <p:nvSpPr>
+          <p:cNvPr id="25" name="Text 19"/>
+          <p:cNvSpPr txBox="1"/>
+          <p:nvPr/>
+        </p:nvSpPr>
+        <p:spPr>
+          <a:xfrm>
+            <a:off x="4764024" y="4398264"/>
+            <a:ext cx="1408176" cy="338328"/>
+          </a:xfrm>
+          <a:prstGeom prst="rect">
+            <a:avLst/>
+          </a:prstGeom>
+          <a:noFill/>
+          <a:ln/>
+        </p:spPr>
+        <p:txBody>
+          <a:bodyPr wrap="square" lIns="0" tIns="0" rIns="0" bIns="0" rtlCol="0" anchor="ctr"/>
+          <a:lstStyle/>
+          <a:p>
+            <a:pPr algn="l" indent="0" marL="0">
+              <a:buNone/>
             </a:pPr>
             <a:r>
-              <a:rPr lang="en-US" sz="1050" dirty="0">
+              <a:rPr lang="en-US" sz="1150" b="1" dirty="0">
                 <a:solidFill>
                   <a:srgbClr val="CADCFC"/>
                 </a:solidFill>
@@ -1787,23 +1981,82 @@
                 <a:ea typeface="Calibri" pitchFamily="34" charset="-122"/>
                 <a:cs typeface="Calibri" pitchFamily="34" charset="-120"/>
               </a:rPr>
-              <a:t>KYC/CIP &amp; AML/OFAC execution</a:t>
-            </a:r>
-            <a:endParaRPr lang="en-US" sz="1050" dirty="0"/>
-          </a:p>
-          <a:p>
-            <a:pPr algn="l" marL="342900" indent="-342900">
-              <a:lnSpc>
-                <a:spcPct val="130000"/>
-              </a:lnSpc>
-              <a:spcAft>
-                <a:spcPts val="900"/>
-              </a:spcAft>
-              <a:buSzPct val="100000"/>
-              <a:buChar char="•"/>
+              <a:t>Customer Info</a:t>
+            </a:r>
+            <a:endParaRPr lang="en-US" sz="1150" dirty="0"/>
+          </a:p>
+        </p:txBody>
+      </p:sp>
+      <p:sp>
+        <p:nvSpPr>
+          <p:cNvPr id="26" name="Shape 20"/>
+          <p:cNvSpPr/>
+          <p:nvPr/>
+        </p:nvSpPr>
+        <p:spPr>
+          <a:xfrm>
+            <a:off x="4361688" y="4805172"/>
+            <a:ext cx="274320" cy="274320"/>
+          </a:xfrm>
+          <a:prstGeom prst="ellipse">
+            <a:avLst/>
+          </a:prstGeom>
+          <a:solidFill>
+            <a:srgbClr val="3A4694"/>
+          </a:solidFill>
+          <a:ln/>
+        </p:spPr>
+      </p:sp>
+      <p:pic>
+        <p:nvPicPr>
+          <p:cNvPr id="27" name="Image 4" descr="preencoded.png">    </p:cNvPr>
+          <p:cNvPicPr>
+            <a:picLocks noChangeAspect="1"/>
+          </p:cNvPicPr>
+          <p:nvPr/>
+        </p:nvPicPr>
+        <p:blipFill>
+          <a:blip r:embed="rId5"/>
+          <a:stretch>
+            <a:fillRect/>
+          </a:stretch>
+        </p:blipFill>
+        <p:spPr>
+          <a:xfrm>
+            <a:off x="4433011" y="4876495"/>
+            <a:ext cx="131674" cy="131674"/>
+          </a:xfrm>
+          <a:prstGeom prst="rect">
+            <a:avLst/>
+          </a:prstGeom>
+        </p:spPr>
+      </p:pic>
+      <p:sp>
+        <p:nvSpPr>
+          <p:cNvPr id="28" name="Text 21"/>
+          <p:cNvSpPr txBox="1"/>
+          <p:nvPr/>
+        </p:nvSpPr>
+        <p:spPr>
+          <a:xfrm>
+            <a:off x="4764024" y="4773168"/>
+            <a:ext cx="1408176" cy="338328"/>
+          </a:xfrm>
+          <a:prstGeom prst="rect">
+            <a:avLst/>
+          </a:prstGeom>
+          <a:noFill/>
+          <a:ln/>
+        </p:spPr>
+        <p:txBody>
+          <a:bodyPr wrap="square" lIns="0" tIns="0" rIns="0" bIns="0" rtlCol="0" anchor="ctr"/>
+          <a:lstStyle/>
+          <a:p>
+            <a:pPr algn="l" indent="0" marL="0">
+              <a:buNone/>
             </a:pPr>
             <a:r>
-              <a:rPr lang="en-US" sz="1050" dirty="0">
+              <a:rPr lang="en-US" sz="1150" b="1" dirty="0">
                 <a:solidFill>
                   <a:srgbClr val="CADCFC"/>
                 </a:solidFill>
@@ -1811,15 +2064,181 @@
                 <a:ea typeface="Calibri" pitchFamily="34" charset="-122"/>
                 <a:cs typeface="Calibri" pitchFamily="34" charset="-120"/>
               </a:rPr>
-              <a:t>Statements, confirms &amp; tax reporting</a:t>
-            </a:r>
-            <a:endParaRPr lang="en-US" sz="1050" dirty="0"/>
+              <a:t>Tax Info</a:t>
+            </a:r>
+            <a:endParaRPr lang="en-US" sz="1150" dirty="0"/>
           </a:p>
         </p:txBody>
       </p:sp>
       <p:sp>
         <p:nvSpPr>
-          <p:cNvPr id="17" name="Shape 14"/>
+          <p:cNvPr id="29" name="Shape 22"/>
+          <p:cNvSpPr/>
+          <p:nvPr/>
+        </p:nvSpPr>
+        <p:spPr>
+          <a:xfrm>
+            <a:off x="4361688" y="5180076"/>
+            <a:ext cx="274320" cy="274320"/>
+          </a:xfrm>
+          <a:prstGeom prst="ellipse">
+            <a:avLst/>
+          </a:prstGeom>
+          <a:solidFill>
+            <a:srgbClr val="3A4694"/>
+          </a:solidFill>
+          <a:ln/>
+        </p:spPr>
+      </p:sp>
+      <p:pic>
+        <p:nvPicPr>
+          <p:cNvPr id="30" name="Image 5" descr="preencoded.png">    </p:cNvPr>
+          <p:cNvPicPr>
+            <a:picLocks noChangeAspect="1"/>
+          </p:cNvPicPr>
+          <p:nvPr/>
+        </p:nvPicPr>
+        <p:blipFill>
+          <a:blip r:embed="rId6"/>
+          <a:stretch>
+            <a:fillRect/>
+          </a:stretch>
+        </p:blipFill>
+        <p:spPr>
+          <a:xfrm>
+            <a:off x="4433011" y="5251399"/>
+            <a:ext cx="131674" cy="131674"/>
+          </a:xfrm>
+          <a:prstGeom prst="rect">
+            <a:avLst/>
+          </a:prstGeom>
+        </p:spPr>
+      </p:pic>
+      <p:sp>
+        <p:nvSpPr>
+          <p:cNvPr id="31" name="Text 23"/>
+          <p:cNvSpPr txBox="1"/>
+          <p:nvPr/>
+        </p:nvSpPr>
+        <p:spPr>
+          <a:xfrm>
+            <a:off x="4764024" y="5148072"/>
+            <a:ext cx="1408176" cy="338328"/>
+          </a:xfrm>
+          <a:prstGeom prst="rect">
+            <a:avLst/>
+          </a:prstGeom>
+          <a:noFill/>
+          <a:ln/>
+        </p:spPr>
+        <p:txBody>
+          <a:bodyPr wrap="square" lIns="0" tIns="0" rIns="0" bIns="0" rtlCol="0" anchor="ctr"/>
+          <a:lstStyle/>
+          <a:p>
+            <a:pPr algn="l" indent="0" marL="0">
+              <a:buNone/>
+            </a:pPr>
+            <a:r>
+              <a:rPr lang="en-US" sz="1150" b="1" dirty="0">
+                <a:solidFill>
+                  <a:srgbClr val="CADCFC"/>
+                </a:solidFill>
+                <a:latin typeface="Calibri" pitchFamily="34" charset="0"/>
+                <a:ea typeface="Calibri" pitchFamily="34" charset="-122"/>
+                <a:cs typeface="Calibri" pitchFamily="34" charset="-120"/>
+              </a:rPr>
+              <a:t>Dividends</a:t>
+            </a:r>
+            <a:endParaRPr lang="en-US" sz="1150" dirty="0"/>
+          </a:p>
+        </p:txBody>
+      </p:sp>
+      <p:sp>
+        <p:nvSpPr>
+          <p:cNvPr id="32" name="Shape 24"/>
+          <p:cNvSpPr/>
+          <p:nvPr/>
+        </p:nvSpPr>
+        <p:spPr>
+          <a:xfrm>
+            <a:off x="4361688" y="5554980"/>
+            <a:ext cx="274320" cy="274320"/>
+          </a:xfrm>
+          <a:prstGeom prst="ellipse">
+            <a:avLst/>
+          </a:prstGeom>
+          <a:solidFill>
+            <a:srgbClr val="3A4694"/>
+          </a:solidFill>
+          <a:ln/>
+        </p:spPr>
+      </p:sp>
+      <p:pic>
+        <p:nvPicPr>
+          <p:cNvPr id="33" name="Image 6" descr="preencoded.png">    </p:cNvPr>
+          <p:cNvPicPr>
+            <a:picLocks noChangeAspect="1"/>
+          </p:cNvPicPr>
+          <p:nvPr/>
+        </p:nvPicPr>
+        <p:blipFill>
+          <a:blip r:embed="rId7"/>
+          <a:stretch>
+            <a:fillRect/>
+          </a:stretch>
+        </p:blipFill>
+        <p:spPr>
+          <a:xfrm>
+            <a:off x="4433011" y="5626303"/>
+            <a:ext cx="131674" cy="131674"/>
+          </a:xfrm>
+          <a:prstGeom prst="rect">
+            <a:avLst/>
+          </a:prstGeom>
+        </p:spPr>
+      </p:pic>
+      <p:sp>
+        <p:nvSpPr>
+          <p:cNvPr id="34" name="Text 25"/>
+          <p:cNvSpPr txBox="1"/>
+          <p:nvPr/>
+        </p:nvSpPr>
+        <p:spPr>
+          <a:xfrm>
+            <a:off x="4764024" y="5522976"/>
+            <a:ext cx="1408176" cy="338328"/>
+          </a:xfrm>
+          <a:prstGeom prst="rect">
+            <a:avLst/>
+          </a:prstGeom>
+          <a:noFill/>
+          <a:ln/>
+        </p:spPr>
+        <p:txBody>
+          <a:bodyPr wrap="square" lIns="0" tIns="0" rIns="0" bIns="0" rtlCol="0" anchor="ctr"/>
+          <a:lstStyle/>
+          <a:p>
+            <a:pPr algn="l" indent="0" marL="0">
+              <a:buNone/>
+            </a:pPr>
+            <a:r>
+              <a:rPr lang="en-US" sz="1150" b="1" dirty="0">
+                <a:solidFill>
+                  <a:srgbClr val="CADCFC"/>
+                </a:solidFill>
+                <a:latin typeface="Calibri" pitchFamily="34" charset="0"/>
+                <a:ea typeface="Calibri" pitchFamily="34" charset="-122"/>
+                <a:cs typeface="Calibri" pitchFamily="34" charset="-120"/>
+              </a:rPr>
+              <a:t>Holdings</a:t>
+            </a:r>
+            <a:endParaRPr lang="en-US" sz="1150" dirty="0"/>
+          </a:p>
+        </p:txBody>
+      </p:sp>
+      <p:sp>
+        <p:nvSpPr>
+          <p:cNvPr id="35" name="Shape 26"/>
           <p:cNvSpPr/>
           <p:nvPr/>
         </p:nvSpPr>
@@ -1832,7 +2251,7 @@
             <a:avLst/>
           </a:prstGeom>
           <a:noFill/>
-          <a:ln w="19050">
+          <a:ln w="22225">
             <a:solidFill>
               <a:srgbClr val="1E2761"/>
             </a:solidFill>
@@ -1844,7 +2263,7 @@
       </p:sp>
       <p:sp>
         <p:nvSpPr>
-          <p:cNvPr id="18" name="Shape 15"/>
+          <p:cNvPr id="36" name="Shape 27"/>
           <p:cNvSpPr/>
           <p:nvPr/>
         </p:nvSpPr>
@@ -1857,7 +2276,7 @@
             <a:avLst/>
           </a:prstGeom>
           <a:noFill/>
-          <a:ln w="19050">
+          <a:ln w="22225">
             <a:solidFill>
               <a:srgbClr val="1E2761"/>
             </a:solidFill>
@@ -1869,7 +2288,7 @@
       </p:sp>
       <p:sp>
         <p:nvSpPr>
-          <p:cNvPr id="19" name="Shape 16"/>
+          <p:cNvPr id="37" name="Shape 28"/>
           <p:cNvSpPr/>
           <p:nvPr/>
         </p:nvSpPr>
@@ -1882,7 +2301,7 @@
             <a:avLst/>
           </a:prstGeom>
           <a:noFill/>
-          <a:ln w="19050">
+          <a:ln w="22225">
             <a:solidFill>
               <a:srgbClr val="1E2761"/>
             </a:solidFill>
@@ -1894,7 +2313,7 @@
       </p:sp>
       <p:sp>
         <p:nvSpPr>
-          <p:cNvPr id="20" name="Shape 17"/>
+          <p:cNvPr id="38" name="Shape 29"/>
           <p:cNvSpPr/>
           <p:nvPr/>
         </p:nvSpPr>
@@ -1907,7 +2326,7 @@
             <a:avLst/>
           </a:prstGeom>
           <a:noFill/>
-          <a:ln w="19050">
+          <a:ln w="22225">
             <a:solidFill>
               <a:srgbClr val="1E2761"/>
             </a:solidFill>
@@ -1919,7 +2338,7 @@
       </p:sp>
       <p:sp>
         <p:nvSpPr>
-          <p:cNvPr id="21" name="Shape 18"/>
+          <p:cNvPr id="39" name="Shape 30"/>
           <p:cNvSpPr/>
           <p:nvPr/>
         </p:nvSpPr>
@@ -1932,7 +2351,7 @@
             <a:avLst/>
           </a:prstGeom>
           <a:noFill/>
-          <a:ln w="19050">
+          <a:ln w="22225">
             <a:solidFill>
               <a:srgbClr val="1E2761"/>
             </a:solidFill>
@@ -1944,7 +2363,7 @@
       </p:sp>
       <p:sp>
         <p:nvSpPr>
-          <p:cNvPr id="22" name="Shape 19"/>
+          <p:cNvPr id="40" name="Shape 31"/>
           <p:cNvSpPr/>
           <p:nvPr/>
         </p:nvSpPr>
@@ -1957,7 +2376,7 @@
             <a:avLst/>
           </a:prstGeom>
           <a:noFill/>
-          <a:ln w="19050">
+          <a:ln w="22225">
             <a:solidFill>
               <a:srgbClr val="C89B3C"/>
             </a:solidFill>
@@ -1968,7 +2387,7 @@
       </p:sp>
       <p:sp>
         <p:nvSpPr>
-          <p:cNvPr id="23" name="Shape 20"/>
+          <p:cNvPr id="41" name="Shape 32"/>
           <p:cNvSpPr/>
           <p:nvPr/>
         </p:nvSpPr>
@@ -1981,7 +2400,7 @@
             <a:avLst/>
           </a:prstGeom>
           <a:noFill/>
-          <a:ln w="19050">
+          <a:ln w="22225">
             <a:solidFill>
               <a:srgbClr val="1E2761"/>
             </a:solidFill>
@@ -1993,7 +2412,7 @@
       </p:sp>
       <p:sp>
         <p:nvSpPr>
-          <p:cNvPr id="24" name="Shape 21"/>
+          <p:cNvPr id="42" name="Shape 33"/>
           <p:cNvSpPr/>
           <p:nvPr/>
         </p:nvSpPr>
@@ -2006,7 +2425,7 @@
             <a:avLst/>
           </a:prstGeom>
           <a:noFill/>
-          <a:ln w="19050">
+          <a:ln w="22225">
             <a:solidFill>
               <a:srgbClr val="1E2761"/>
             </a:solidFill>
@@ -2018,7 +2437,7 @@
       </p:sp>
       <p:sp>
         <p:nvSpPr>
-          <p:cNvPr id="25" name="Shape 22"/>
+          <p:cNvPr id="43" name="Shape 34"/>
           <p:cNvSpPr/>
           <p:nvPr/>
         </p:nvSpPr>
@@ -2031,7 +2450,7 @@
             <a:avLst/>
           </a:prstGeom>
           <a:noFill/>
-          <a:ln w="19050">
+          <a:ln w="22225">
             <a:solidFill>
               <a:srgbClr val="C89B3C"/>
             </a:solidFill>
@@ -2042,7 +2461,7 @@
       </p:sp>
       <p:sp>
         <p:nvSpPr>
-          <p:cNvPr id="26" name="Shape 23"/>
+          <p:cNvPr id="44" name="Shape 35"/>
           <p:cNvSpPr/>
           <p:nvPr/>
         </p:nvSpPr>
@@ -2055,7 +2474,7 @@
             <a:avLst/>
           </a:prstGeom>
           <a:noFill/>
-          <a:ln w="19050">
+          <a:ln w="22225">
             <a:solidFill>
               <a:srgbClr val="C89B3C"/>
             </a:solidFill>
@@ -2066,7 +2485,7 @@
       </p:sp>
       <p:sp>
         <p:nvSpPr>
-          <p:cNvPr id="27" name="Shape 24"/>
+          <p:cNvPr id="45" name="Shape 36"/>
           <p:cNvSpPr/>
           <p:nvPr/>
         </p:nvSpPr>
@@ -2079,7 +2498,7 @@
             <a:avLst/>
           </a:prstGeom>
           <a:noFill/>
-          <a:ln w="19050">
+          <a:ln w="22225">
             <a:solidFill>
               <a:srgbClr val="1E2761"/>
             </a:solidFill>
@@ -2091,7 +2510,7 @@
       </p:sp>
       <p:sp>
         <p:nvSpPr>
-          <p:cNvPr id="28" name="Shape 25"/>
+          <p:cNvPr id="46" name="Shape 37"/>
           <p:cNvSpPr/>
           <p:nvPr/>
         </p:nvSpPr>
@@ -2104,7 +2523,7 @@
             <a:avLst/>
           </a:prstGeom>
           <a:noFill/>
-          <a:ln w="19050">
+          <a:ln w="22225">
             <a:solidFill>
               <a:srgbClr val="C89B3C"/>
             </a:solidFill>
@@ -2115,7 +2534,7 @@
       </p:sp>
       <p:sp>
         <p:nvSpPr>
-          <p:cNvPr id="29" name="Shape 26"/>
+          <p:cNvPr id="47" name="Shape 38"/>
           <p:cNvSpPr/>
           <p:nvPr/>
         </p:nvSpPr>
@@ -2128,7 +2547,7 @@
             <a:avLst/>
           </a:prstGeom>
           <a:noFill/>
-          <a:ln w="19050">
+          <a:ln w="22225">
             <a:solidFill>
               <a:srgbClr val="C89B3C"/>
             </a:solidFill>
@@ -2139,7 +2558,7 @@
       </p:sp>
       <p:sp>
         <p:nvSpPr>
-          <p:cNvPr id="30" name="Shape 27"/>
+          <p:cNvPr id="48" name="Shape 39"/>
           <p:cNvSpPr/>
           <p:nvPr/>
         </p:nvSpPr>
@@ -2150,7 +2569,7 @@
           </a:xfrm>
           <a:prstGeom prst="roundRect">
             <a:avLst>
-              <a:gd name="adj" fmla="val 8235"/>
+              <a:gd name="adj" fmla="val 9412"/>
             </a:avLst>
           </a:prstGeom>
           <a:solidFill>
@@ -2162,11 +2581,18 @@
             </a:solidFill>
             <a:prstDash val="solid"/>
           </a:ln>
-        </p:spPr>
-      </p:sp>
-      <p:sp>
-        <p:nvSpPr>
-          <p:cNvPr id="31" name="Shape 28"/>
+          <a:effectLst>
+            <a:outerShdw sx="100000" sy="100000" kx="0" ky="0" algn="bl" rotWithShape="0" blurRad="63500" dist="25400" dir="5400000">
+              <a:srgbClr val="9AA7C7">
+                <a:alpha val="32000"/>
+              </a:srgbClr>
+            </a:outerShdw>
+          </a:effectLst>
+        </p:spPr>
+      </p:sp>
+      <p:sp>
+        <p:nvSpPr>
+          <p:cNvPr id="49" name="Shape 40"/>
           <p:cNvSpPr/>
           <p:nvPr/>
         </p:nvSpPr>
@@ -2186,14 +2612,14 @@
       </p:sp>
       <p:pic>
         <p:nvPicPr>
-          <p:cNvPr id="32" name="Image 1" descr="preencoded.png">    </p:cNvPr>
+          <p:cNvPr id="50" name="Image 7" descr="preencoded.png">    </p:cNvPr>
           <p:cNvPicPr>
             <a:picLocks noChangeAspect="1"/>
           </p:cNvPicPr>
           <p:nvPr/>
         </p:nvPicPr>
         <p:blipFill>
-          <a:blip r:embed="rId2"/>
+          <a:blip r:embed="rId8"/>
           <a:stretch>
             <a:fillRect/>
           </a:stretch>
@@ -2210,7 +2636,7 @@
       </p:pic>
       <p:sp>
         <p:nvSpPr>
-          <p:cNvPr id="33" name="Text 29"/>
+          <p:cNvPr id="51" name="Text 41"/>
           <p:cNvSpPr txBox="1"/>
           <p:nvPr/>
         </p:nvSpPr>
@@ -2272,7 +2698,7 @@
       </p:sp>
       <p:sp>
         <p:nvSpPr>
-          <p:cNvPr id="34" name="Shape 30"/>
+          <p:cNvPr id="52" name="Shape 42"/>
           <p:cNvSpPr/>
           <p:nvPr/>
         </p:nvSpPr>
@@ -2283,7 +2709,7 @@
           </a:xfrm>
           <a:prstGeom prst="roundRect">
             <a:avLst>
-              <a:gd name="adj" fmla="val 8235"/>
+              <a:gd name="adj" fmla="val 9412"/>
             </a:avLst>
           </a:prstGeom>
           <a:solidFill>
@@ -2295,11 +2721,18 @@
             </a:solidFill>
             <a:prstDash val="solid"/>
           </a:ln>
-        </p:spPr>
-      </p:sp>
-      <p:sp>
-        <p:nvSpPr>
-          <p:cNvPr id="35" name="Shape 31"/>
+          <a:effectLst>
+            <a:outerShdw sx="100000" sy="100000" kx="0" ky="0" algn="bl" rotWithShape="0" blurRad="63500" dist="25400" dir="5400000">
+              <a:srgbClr val="9AA7C7">
+                <a:alpha val="32000"/>
+              </a:srgbClr>
+            </a:outerShdw>
+          </a:effectLst>
+        </p:spPr>
+      </p:sp>
+      <p:sp>
+        <p:nvSpPr>
+          <p:cNvPr id="53" name="Shape 43"/>
           <p:cNvSpPr/>
           <p:nvPr/>
         </p:nvSpPr>
@@ -2319,14 +2752,14 @@
       </p:sp>
       <p:pic>
         <p:nvPicPr>
-          <p:cNvPr id="36" name="Image 2" descr="preencoded.png">    </p:cNvPr>
+          <p:cNvPr id="54" name="Image 8" descr="preencoded.png">    </p:cNvPr>
           <p:cNvPicPr>
             <a:picLocks noChangeAspect="1"/>
           </p:cNvPicPr>
           <p:nvPr/>
         </p:nvPicPr>
         <p:blipFill>
-          <a:blip r:embed="rId3"/>
+          <a:blip r:embed="rId9"/>
           <a:stretch>
             <a:fillRect/>
           </a:stretch>
@@ -2343,7 +2776,7 @@
       </p:pic>
       <p:sp>
         <p:nvSpPr>
-          <p:cNvPr id="37" name="Text 32"/>
+          <p:cNvPr id="55" name="Text 44"/>
           <p:cNvSpPr txBox="1"/>
           <p:nvPr/>
         </p:nvSpPr>
@@ -2405,7 +2838,7 @@
       </p:sp>
       <p:sp>
         <p:nvSpPr>
-          <p:cNvPr id="38" name="Shape 33"/>
+          <p:cNvPr id="56" name="Shape 45"/>
           <p:cNvSpPr/>
           <p:nvPr/>
         </p:nvSpPr>
@@ -2416,7 +2849,7 @@
           </a:xfrm>
           <a:prstGeom prst="roundRect">
             <a:avLst>
-              <a:gd name="adj" fmla="val 8235"/>
+              <a:gd name="adj" fmla="val 9412"/>
             </a:avLst>
           </a:prstGeom>
           <a:solidFill>
@@ -2428,11 +2861,18 @@
             </a:solidFill>
             <a:prstDash val="solid"/>
           </a:ln>
-        </p:spPr>
-      </p:sp>
-      <p:sp>
-        <p:nvSpPr>
-          <p:cNvPr id="39" name="Shape 34"/>
+          <a:effectLst>
+            <a:outerShdw sx="100000" sy="100000" kx="0" ky="0" algn="bl" rotWithShape="0" blurRad="63500" dist="25400" dir="5400000">
+              <a:srgbClr val="9AA7C7">
+                <a:alpha val="32000"/>
+              </a:srgbClr>
+            </a:outerShdw>
+          </a:effectLst>
+        </p:spPr>
+      </p:sp>
+      <p:sp>
+        <p:nvSpPr>
+          <p:cNvPr id="57" name="Shape 46"/>
           <p:cNvSpPr/>
           <p:nvPr/>
         </p:nvSpPr>
@@ -2452,14 +2892,14 @@
       </p:sp>
       <p:pic>
         <p:nvPicPr>
-          <p:cNvPr id="40" name="Image 3" descr="preencoded.png">    </p:cNvPr>
+          <p:cNvPr id="58" name="Image 9" descr="preencoded.png">    </p:cNvPr>
           <p:cNvPicPr>
             <a:picLocks noChangeAspect="1"/>
           </p:cNvPicPr>
           <p:nvPr/>
         </p:nvPicPr>
         <p:blipFill>
-          <a:blip r:embed="rId4"/>
+          <a:blip r:embed="rId10"/>
           <a:stretch>
             <a:fillRect/>
           </a:stretch>
@@ -2476,7 +2916,7 @@
       </p:pic>
       <p:sp>
         <p:nvSpPr>
-          <p:cNvPr id="41" name="Text 35"/>
+          <p:cNvPr id="59" name="Text 47"/>
           <p:cNvSpPr txBox="1"/>
           <p:nvPr/>
         </p:nvSpPr>
@@ -2538,7 +2978,7 @@
       </p:sp>
       <p:sp>
         <p:nvSpPr>
-          <p:cNvPr id="42" name="Shape 36"/>
+          <p:cNvPr id="60" name="Shape 48"/>
           <p:cNvSpPr/>
           <p:nvPr/>
         </p:nvSpPr>
@@ -2549,7 +2989,7 @@
           </a:xfrm>
           <a:prstGeom prst="roundRect">
             <a:avLst>
-              <a:gd name="adj" fmla="val 8235"/>
+              <a:gd name="adj" fmla="val 9412"/>
             </a:avLst>
           </a:prstGeom>
           <a:solidFill>
@@ -2561,11 +3001,18 @@
             </a:solidFill>
             <a:prstDash val="solid"/>
           </a:ln>
-        </p:spPr>
-      </p:sp>
-      <p:sp>
-        <p:nvSpPr>
-          <p:cNvPr id="43" name="Shape 37"/>
+          <a:effectLst>
+            <a:outerShdw sx="100000" sy="100000" kx="0" ky="0" algn="bl" rotWithShape="0" blurRad="63500" dist="25400" dir="5400000">
+              <a:srgbClr val="9AA7C7">
+                <a:alpha val="32000"/>
+              </a:srgbClr>
+            </a:outerShdw>
+          </a:effectLst>
+        </p:spPr>
+      </p:sp>
+      <p:sp>
+        <p:nvSpPr>
+          <p:cNvPr id="61" name="Shape 49"/>
           <p:cNvSpPr/>
           <p:nvPr/>
         </p:nvSpPr>
@@ -2585,14 +3032,14 @@
       </p:sp>
       <p:pic>
         <p:nvPicPr>
-          <p:cNvPr id="44" name="Image 4" descr="preencoded.png">    </p:cNvPr>
+          <p:cNvPr id="62" name="Image 10" descr="preencoded.png">    </p:cNvPr>
           <p:cNvPicPr>
             <a:picLocks noChangeAspect="1"/>
           </p:cNvPicPr>
           <p:nvPr/>
         </p:nvPicPr>
         <p:blipFill>
-          <a:blip r:embed="rId5"/>
+          <a:blip r:embed="rId11"/>
           <a:stretch>
             <a:fillRect/>
           </a:stretch>
@@ -2609,7 +3056,7 @@
       </p:pic>
       <p:sp>
         <p:nvSpPr>
-          <p:cNvPr id="45" name="Text 38"/>
+          <p:cNvPr id="63" name="Text 50"/>
           <p:cNvSpPr txBox="1"/>
           <p:nvPr/>
         </p:nvSpPr>
@@ -2671,7 +3118,7 @@
       </p:sp>
       <p:sp>
         <p:nvSpPr>
-          <p:cNvPr id="46" name="Shape 39"/>
+          <p:cNvPr id="64" name="Shape 51"/>
           <p:cNvSpPr/>
           <p:nvPr/>
         </p:nvSpPr>
@@ -2682,7 +3129,7 @@
           </a:xfrm>
           <a:prstGeom prst="roundRect">
             <a:avLst>
-              <a:gd name="adj" fmla="val 14000"/>
+              <a:gd name="adj" fmla="val 16000"/>
             </a:avLst>
           </a:prstGeom>
           <a:solidFill>
@@ -2694,11 +3141,18 @@
             </a:solidFill>
             <a:prstDash val="solid"/>
           </a:ln>
-        </p:spPr>
-      </p:sp>
-      <p:sp>
-        <p:nvSpPr>
-          <p:cNvPr id="47" name="Shape 40"/>
+          <a:effectLst>
+            <a:outerShdw sx="100000" sy="100000" kx="0" ky="0" algn="bl" rotWithShape="0" blurRad="63500" dist="25400" dir="5400000">
+              <a:srgbClr val="9AA7C7">
+                <a:alpha val="32000"/>
+              </a:srgbClr>
+            </a:outerShdw>
+          </a:effectLst>
+        </p:spPr>
+      </p:sp>
+      <p:sp>
+        <p:nvSpPr>
+          <p:cNvPr id="65" name="Shape 52"/>
           <p:cNvSpPr/>
           <p:nvPr/>
         </p:nvSpPr>
@@ -2718,14 +3172,14 @@
       </p:sp>
       <p:pic>
         <p:nvPicPr>
-          <p:cNvPr id="48" name="Image 5" descr="preencoded.png">    </p:cNvPr>
+          <p:cNvPr id="66" name="Image 11" descr="preencoded.png">    </p:cNvPr>
           <p:cNvPicPr>
             <a:picLocks noChangeAspect="1"/>
           </p:cNvPicPr>
           <p:nvPr/>
         </p:nvPicPr>
         <p:blipFill>
-          <a:blip r:embed="rId6"/>
+          <a:blip r:embed="rId12"/>
           <a:stretch>
             <a:fillRect/>
           </a:stretch>
@@ -2742,7 +3196,7 @@
       </p:pic>
       <p:sp>
         <p:nvSpPr>
-          <p:cNvPr id="49" name="Text 41"/>
+          <p:cNvPr id="67" name="Text 53"/>
           <p:cNvSpPr txBox="1"/>
           <p:nvPr/>
         </p:nvSpPr>
@@ -2784,7 +3238,7 @@
       </p:sp>
       <p:sp>
         <p:nvSpPr>
-          <p:cNvPr id="50" name="Shape 42"/>
+          <p:cNvPr id="68" name="Shape 54"/>
           <p:cNvSpPr/>
           <p:nvPr/>
         </p:nvSpPr>
@@ -2795,7 +3249,7 @@
           </a:xfrm>
           <a:prstGeom prst="roundRect">
             <a:avLst>
-              <a:gd name="adj" fmla="val 14000"/>
+              <a:gd name="adj" fmla="val 16000"/>
             </a:avLst>
           </a:prstGeom>
           <a:solidFill>
@@ -2807,11 +3261,18 @@
             </a:solidFill>
             <a:prstDash val="solid"/>
           </a:ln>
-        </p:spPr>
-      </p:sp>
-      <p:sp>
-        <p:nvSpPr>
-          <p:cNvPr id="51" name="Shape 43"/>
+          <a:effectLst>
+            <a:outerShdw sx="100000" sy="100000" kx="0" ky="0" algn="bl" rotWithShape="0" blurRad="63500" dist="25400" dir="5400000">
+              <a:srgbClr val="9AA7C7">
+                <a:alpha val="32000"/>
+              </a:srgbClr>
+            </a:outerShdw>
+          </a:effectLst>
+        </p:spPr>
+      </p:sp>
+      <p:sp>
+        <p:nvSpPr>
+          <p:cNvPr id="69" name="Shape 55"/>
           <p:cNvSpPr/>
           <p:nvPr/>
         </p:nvSpPr>
@@ -2831,14 +3292,14 @@
       </p:sp>
       <p:pic>
         <p:nvPicPr>
-          <p:cNvPr id="52" name="Image 6" descr="preencoded.png">    </p:cNvPr>
+          <p:cNvPr id="70" name="Image 12" descr="preencoded.png">    </p:cNvPr>
           <p:cNvPicPr>
             <a:picLocks noChangeAspect="1"/>
           </p:cNvPicPr>
           <p:nvPr/>
         </p:nvPicPr>
         <p:blipFill>
-          <a:blip r:embed="rId7"/>
+          <a:blip r:embed="rId13"/>
           <a:stretch>
             <a:fillRect/>
           </a:stretch>
@@ -2855,7 +3316,7 @@
       </p:pic>
       <p:sp>
         <p:nvSpPr>
-          <p:cNvPr id="53" name="Text 44"/>
+          <p:cNvPr id="71" name="Text 56"/>
           <p:cNvSpPr txBox="1"/>
           <p:nvPr/>
         </p:nvSpPr>
@@ -2917,7 +3378,7 @@
       </p:sp>
       <p:sp>
         <p:nvSpPr>
-          <p:cNvPr id="54" name="Shape 45"/>
+          <p:cNvPr id="72" name="Shape 57"/>
           <p:cNvSpPr/>
           <p:nvPr/>
         </p:nvSpPr>
@@ -2928,7 +3389,7 @@
           </a:xfrm>
           <a:prstGeom prst="roundRect">
             <a:avLst>
-              <a:gd name="adj" fmla="val 14000"/>
+              <a:gd name="adj" fmla="val 16000"/>
             </a:avLst>
           </a:prstGeom>
           <a:solidFill>
@@ -2940,11 +3401,18 @@
             </a:solidFill>
             <a:prstDash val="solid"/>
           </a:ln>
-        </p:spPr>
-      </p:sp>
-      <p:sp>
-        <p:nvSpPr>
-          <p:cNvPr id="55" name="Shape 46"/>
+          <a:effectLst>
+            <a:outerShdw sx="100000" sy="100000" kx="0" ky="0" algn="bl" rotWithShape="0" blurRad="63500" dist="25400" dir="5400000">
+              <a:srgbClr val="9AA7C7">
+                <a:alpha val="32000"/>
+              </a:srgbClr>
+            </a:outerShdw>
+          </a:effectLst>
+        </p:spPr>
+      </p:sp>
+      <p:sp>
+        <p:nvSpPr>
+          <p:cNvPr id="73" name="Shape 58"/>
           <p:cNvSpPr/>
           <p:nvPr/>
         </p:nvSpPr>
@@ -2964,14 +3432,14 @@
       </p:sp>
       <p:pic>
         <p:nvPicPr>
-          <p:cNvPr id="56" name="Image 7" descr="preencoded.png">    </p:cNvPr>
+          <p:cNvPr id="74" name="Image 13" descr="preencoded.png">    </p:cNvPr>
           <p:cNvPicPr>
             <a:picLocks noChangeAspect="1"/>
           </p:cNvPicPr>
           <p:nvPr/>
         </p:nvPicPr>
         <p:blipFill>
-          <a:blip r:embed="rId8"/>
+          <a:blip r:embed="rId14"/>
           <a:stretch>
             <a:fillRect/>
           </a:stretch>
@@ -2988,7 +3456,7 @@
       </p:pic>
       <p:sp>
         <p:nvSpPr>
-          <p:cNvPr id="57" name="Text 47"/>
+          <p:cNvPr id="75" name="Text 59"/>
           <p:cNvSpPr txBox="1"/>
           <p:nvPr/>
         </p:nvSpPr>
@@ -3030,7 +3498,7 @@
       </p:sp>
       <p:sp>
         <p:nvSpPr>
-          <p:cNvPr id="58" name="Shape 48"/>
+          <p:cNvPr id="76" name="Shape 60"/>
           <p:cNvSpPr/>
           <p:nvPr/>
         </p:nvSpPr>
@@ -3041,7 +3509,7 @@
           </a:xfrm>
           <a:prstGeom prst="roundRect">
             <a:avLst>
-              <a:gd name="adj" fmla="val 14000"/>
+              <a:gd name="adj" fmla="val 16000"/>
             </a:avLst>
           </a:prstGeom>
           <a:solidFill>
@@ -3053,11 +3521,18 @@
             </a:solidFill>
             <a:prstDash val="solid"/>
           </a:ln>
-        </p:spPr>
-      </p:sp>
-      <p:sp>
-        <p:nvSpPr>
-          <p:cNvPr id="59" name="Shape 49"/>
+          <a:effectLst>
+            <a:outerShdw sx="100000" sy="100000" kx="0" ky="0" algn="bl" rotWithShape="0" blurRad="63500" dist="25400" dir="5400000">
+              <a:srgbClr val="9AA7C7">
+                <a:alpha val="32000"/>
+              </a:srgbClr>
+            </a:outerShdw>
+          </a:effectLst>
+        </p:spPr>
+      </p:sp>
+      <p:sp>
+        <p:nvSpPr>
+          <p:cNvPr id="77" name="Shape 61"/>
           <p:cNvSpPr/>
           <p:nvPr/>
         </p:nvSpPr>
@@ -3077,14 +3552,14 @@
       </p:sp>
       <p:pic>
         <p:nvPicPr>
-          <p:cNvPr id="60" name="Image 8" descr="preencoded.png">    </p:cNvPr>
+          <p:cNvPr id="78" name="Image 14" descr="preencoded.png">    </p:cNvPr>
           <p:cNvPicPr>
             <a:picLocks noChangeAspect="1"/>
           </p:cNvPicPr>
           <p:nvPr/>
         </p:nvPicPr>
         <p:blipFill>
-          <a:blip r:embed="rId9"/>
+          <a:blip r:embed="rId15"/>
           <a:stretch>
             <a:fillRect/>
           </a:stretch>
@@ -3101,7 +3576,7 @@
       </p:pic>
       <p:sp>
         <p:nvSpPr>
-          <p:cNvPr id="61" name="Text 50"/>
+          <p:cNvPr id="79" name="Text 62"/>
           <p:cNvSpPr txBox="1"/>
           <p:nvPr/>
         </p:nvSpPr>
@@ -3143,7 +3618,7 @@
       </p:sp>
       <p:sp>
         <p:nvSpPr>
-          <p:cNvPr id="62" name="Shape 51"/>
+          <p:cNvPr id="80" name="Shape 63"/>
           <p:cNvSpPr/>
           <p:nvPr/>
         </p:nvSpPr>
@@ -3154,7 +3629,7 @@
           </a:xfrm>
           <a:prstGeom prst="roundRect">
             <a:avLst>
-              <a:gd name="adj" fmla="val 14000"/>
+              <a:gd name="adj" fmla="val 16000"/>
             </a:avLst>
           </a:prstGeom>
           <a:solidFill>
@@ -3166,11 +3641,18 @@
             </a:solidFill>
             <a:prstDash val="solid"/>
           </a:ln>
-        </p:spPr>
-      </p:sp>
-      <p:sp>
-        <p:nvSpPr>
-          <p:cNvPr id="63" name="Shape 52"/>
+          <a:effectLst>
+            <a:outerShdw sx="100000" sy="100000" kx="0" ky="0" algn="bl" rotWithShape="0" blurRad="63500" dist="25400" dir="5400000">
+              <a:srgbClr val="9AA7C7">
+                <a:alpha val="32000"/>
+              </a:srgbClr>
+            </a:outerShdw>
+          </a:effectLst>
+        </p:spPr>
+      </p:sp>
+      <p:sp>
+        <p:nvSpPr>
+          <p:cNvPr id="81" name="Shape 64"/>
           <p:cNvSpPr/>
           <p:nvPr/>
         </p:nvSpPr>
@@ -3190,14 +3672,14 @@
       </p:sp>
       <p:pic>
         <p:nvPicPr>
-          <p:cNvPr id="64" name="Image 9" descr="preencoded.png">    </p:cNvPr>
+          <p:cNvPr id="82" name="Image 15" descr="preencoded.png">    </p:cNvPr>
           <p:cNvPicPr>
             <a:picLocks noChangeAspect="1"/>
           </p:cNvPicPr>
           <p:nvPr/>
         </p:nvPicPr>
         <p:blipFill>
-          <a:blip r:embed="rId10"/>
+          <a:blip r:embed="rId16"/>
           <a:stretch>
             <a:fillRect/>
           </a:stretch>
@@ -3214,7 +3696,7 @@
       </p:pic>
       <p:sp>
         <p:nvSpPr>
-          <p:cNvPr id="65" name="Text 53"/>
+          <p:cNvPr id="83" name="Text 65"/>
           <p:cNvSpPr txBox="1"/>
           <p:nvPr/>
         </p:nvSpPr>
@@ -3256,7 +3738,7 @@
       </p:sp>
       <p:sp>
         <p:nvSpPr>
-          <p:cNvPr id="66" name="Shape 54"/>
+          <p:cNvPr id="84" name="Shape 66"/>
           <p:cNvSpPr/>
           <p:nvPr/>
         </p:nvSpPr>
@@ -3267,7 +3749,7 @@
           </a:xfrm>
           <a:prstGeom prst="roundRect">
             <a:avLst>
-              <a:gd name="adj" fmla="val 14000"/>
+              <a:gd name="adj" fmla="val 16000"/>
             </a:avLst>
           </a:prstGeom>
           <a:solidFill>
@@ -3279,11 +3761,18 @@
             </a:solidFill>
             <a:prstDash val="solid"/>
           </a:ln>
-        </p:spPr>
-      </p:sp>
-      <p:sp>
-        <p:nvSpPr>
-          <p:cNvPr id="67" name="Shape 55"/>
+          <a:effectLst>
+            <a:outerShdw sx="100000" sy="100000" kx="0" ky="0" algn="bl" rotWithShape="0" blurRad="63500" dist="25400" dir="5400000">
+              <a:srgbClr val="9AA7C7">
+                <a:alpha val="32000"/>
+              </a:srgbClr>
+            </a:outerShdw>
+          </a:effectLst>
+        </p:spPr>
+      </p:sp>
+      <p:sp>
+        <p:nvSpPr>
+          <p:cNvPr id="85" name="Shape 67"/>
           <p:cNvSpPr/>
           <p:nvPr/>
         </p:nvSpPr>
@@ -3303,14 +3792,14 @@
       </p:sp>
       <p:pic>
         <p:nvPicPr>
-          <p:cNvPr id="68" name="Image 10" descr="preencoded.png">    </p:cNvPr>
+          <p:cNvPr id="86" name="Image 16" descr="preencoded.png">    </p:cNvPr>
           <p:cNvPicPr>
             <a:picLocks noChangeAspect="1"/>
           </p:cNvPicPr>
           <p:nvPr/>
         </p:nvPicPr>
         <p:blipFill>
-          <a:blip r:embed="rId11"/>
+          <a:blip r:embed="rId17"/>
           <a:stretch>
             <a:fillRect/>
           </a:stretch>
@@ -3327,7 +3816,7 @@
       </p:pic>
       <p:sp>
         <p:nvSpPr>
-          <p:cNvPr id="69" name="Text 56"/>
+          <p:cNvPr id="87" name="Text 68"/>
           <p:cNvSpPr txBox="1"/>
           <p:nvPr/>
         </p:nvSpPr>
@@ -3369,7 +3858,7 @@
       </p:sp>
       <p:sp>
         <p:nvSpPr>
-          <p:cNvPr id="70" name="Shape 57"/>
+          <p:cNvPr id="88" name="Shape 69"/>
           <p:cNvSpPr/>
           <p:nvPr/>
         </p:nvSpPr>
@@ -3380,7 +3869,7 @@
           </a:xfrm>
           <a:prstGeom prst="roundRect">
             <a:avLst>
-              <a:gd name="adj" fmla="val 14000"/>
+              <a:gd name="adj" fmla="val 16000"/>
             </a:avLst>
           </a:prstGeom>
           <a:solidFill>
@@ -3392,11 +3881,18 @@
             </a:solidFill>
             <a:prstDash val="solid"/>
           </a:ln>
-        </p:spPr>
-      </p:sp>
-      <p:sp>
-        <p:nvSpPr>
-          <p:cNvPr id="71" name="Shape 58"/>
+          <a:effectLst>
+            <a:outerShdw sx="100000" sy="100000" kx="0" ky="0" algn="bl" rotWithShape="0" blurRad="63500" dist="25400" dir="5400000">
+              <a:srgbClr val="9AA7C7">
+                <a:alpha val="32000"/>
+              </a:srgbClr>
+            </a:outerShdw>
+          </a:effectLst>
+        </p:spPr>
+      </p:sp>
+      <p:sp>
+        <p:nvSpPr>
+          <p:cNvPr id="89" name="Shape 70"/>
           <p:cNvSpPr/>
           <p:nvPr/>
         </p:nvSpPr>
@@ -3416,14 +3912,14 @@
       </p:sp>
       <p:pic>
         <p:nvPicPr>
-          <p:cNvPr id="72" name="Image 11" descr="preencoded.png">    </p:cNvPr>
+          <p:cNvPr id="90" name="Image 17" descr="preencoded.png">    </p:cNvPr>
           <p:cNvPicPr>
             <a:picLocks noChangeAspect="1"/>
           </p:cNvPicPr>
           <p:nvPr/>
         </p:nvPicPr>
         <p:blipFill>
-          <a:blip r:embed="rId12"/>
+          <a:blip r:embed="rId18"/>
           <a:stretch>
             <a:fillRect/>
           </a:stretch>
@@ -3440,7 +3936,7 @@
       </p:pic>
       <p:sp>
         <p:nvSpPr>
-          <p:cNvPr id="73" name="Text 59"/>
+          <p:cNvPr id="91" name="Text 71"/>
           <p:cNvSpPr txBox="1"/>
           <p:nvPr/>
         </p:nvSpPr>
@@ -3502,7 +3998,7 @@
       </p:sp>
       <p:sp>
         <p:nvSpPr>
-          <p:cNvPr id="74" name="Shape 60"/>
+          <p:cNvPr id="92" name="Shape 72"/>
           <p:cNvSpPr/>
           <p:nvPr/>
         </p:nvSpPr>
@@ -3513,7 +4009,7 @@
           </a:xfrm>
           <a:prstGeom prst="roundRect">
             <a:avLst>
-              <a:gd name="adj" fmla="val 14000"/>
+              <a:gd name="adj" fmla="val 16000"/>
             </a:avLst>
           </a:prstGeom>
           <a:solidFill>
@@ -3525,11 +4021,18 @@
             </a:solidFill>
             <a:prstDash val="solid"/>
           </a:ln>
-        </p:spPr>
-      </p:sp>
-      <p:sp>
-        <p:nvSpPr>
-          <p:cNvPr id="75" name="Shape 61"/>
+          <a:effectLst>
+            <a:outerShdw sx="100000" sy="100000" kx="0" ky="0" algn="bl" rotWithShape="0" blurRad="63500" dist="25400" dir="5400000">
+              <a:srgbClr val="9AA7C7">
+                <a:alpha val="32000"/>
+              </a:srgbClr>
+            </a:outerShdw>
+          </a:effectLst>
+        </p:spPr>
+      </p:sp>
+      <p:sp>
+        <p:nvSpPr>
+          <p:cNvPr id="93" name="Shape 73"/>
           <p:cNvSpPr/>
           <p:nvPr/>
         </p:nvSpPr>
@@ -3549,14 +4052,14 @@
       </p:sp>
       <p:pic>
         <p:nvPicPr>
-          <p:cNvPr id="76" name="Image 12" descr="preencoded.png">    </p:cNvPr>
+          <p:cNvPr id="94" name="Image 18" descr="preencoded.png">    </p:cNvPr>
           <p:cNvPicPr>
             <a:picLocks noChangeAspect="1"/>
           </p:cNvPicPr>
           <p:nvPr/>
         </p:nvPicPr>
         <p:blipFill>
-          <a:blip r:embed="rId13"/>
+          <a:blip r:embed="rId19"/>
           <a:stretch>
             <a:fillRect/>
           </a:stretch>
@@ -3573,7 +4076,7 @@
       </p:pic>
       <p:sp>
         <p:nvSpPr>
-          <p:cNvPr id="77" name="Text 62"/>
+          <p:cNvPr id="95" name="Text 74"/>
           <p:cNvSpPr txBox="1"/>
           <p:nvPr/>
         </p:nvSpPr>
@@ -3635,7 +4138,7 @@
       </p:sp>
       <p:sp>
         <p:nvSpPr>
-          <p:cNvPr id="78" name="Shape 63"/>
+          <p:cNvPr id="96" name="Shape 75"/>
           <p:cNvSpPr/>
           <p:nvPr/>
         </p:nvSpPr>
@@ -3646,7 +4149,7 @@
           </a:xfrm>
           <a:prstGeom prst="roundRect">
             <a:avLst>
-              <a:gd name="adj" fmla="val 14000"/>
+              <a:gd name="adj" fmla="val 16000"/>
             </a:avLst>
           </a:prstGeom>
           <a:solidFill>
@@ -3658,11 +4161,18 @@
             </a:solidFill>
             <a:prstDash val="solid"/>
           </a:ln>
-        </p:spPr>
-      </p:sp>
-      <p:sp>
-        <p:nvSpPr>
-          <p:cNvPr id="79" name="Shape 64"/>
+          <a:effectLst>
+            <a:outerShdw sx="100000" sy="100000" kx="0" ky="0" algn="bl" rotWithShape="0" blurRad="63500" dist="25400" dir="5400000">
+              <a:srgbClr val="9AA7C7">
+                <a:alpha val="32000"/>
+              </a:srgbClr>
+            </a:outerShdw>
+          </a:effectLst>
+        </p:spPr>
+      </p:sp>
+      <p:sp>
+        <p:nvSpPr>
+          <p:cNvPr id="97" name="Shape 76"/>
           <p:cNvSpPr/>
           <p:nvPr/>
         </p:nvSpPr>
@@ -3682,14 +4192,14 @@
       </p:sp>
       <p:pic>
         <p:nvPicPr>
-          <p:cNvPr id="80" name="Image 13" descr="preencoded.png">    </p:cNvPr>
+          <p:cNvPr id="98" name="Image 19" descr="preencoded.png">    </p:cNvPr>
           <p:cNvPicPr>
             <a:picLocks noChangeAspect="1"/>
           </p:cNvPicPr>
           <p:nvPr/>
         </p:nvPicPr>
         <p:blipFill>
-          <a:blip r:embed="rId14"/>
+          <a:blip r:embed="rId20"/>
           <a:stretch>
             <a:fillRect/>
           </a:stretch>
@@ -3706,7 +4216,7 @@
       </p:pic>
       <p:sp>
         <p:nvSpPr>
-          <p:cNvPr id="81" name="Text 65"/>
+          <p:cNvPr id="99" name="Text 77"/>
           <p:cNvSpPr txBox="1"/>
           <p:nvPr/>
         </p:nvSpPr>
@@ -3768,7 +4278,7 @@
       </p:sp>
       <p:sp>
         <p:nvSpPr>
-          <p:cNvPr id="82" name="Text 66"/>
+          <p:cNvPr id="100" name="Text 78"/>
           <p:cNvSpPr txBox="1"/>
           <p:nvPr/>
         </p:nvSpPr>
@@ -3807,7 +4317,7 @@
       </p:sp>
       <p:sp>
         <p:nvSpPr>
-          <p:cNvPr id="83" name="Text 67"/>
+          <p:cNvPr id="101" name="Text 79"/>
           <p:cNvSpPr txBox="1"/>
           <p:nvPr/>
         </p:nvSpPr>
@@ -3846,7 +4356,7 @@
       </p:sp>
       <p:sp>
         <p:nvSpPr>
-          <p:cNvPr id="84" name="Text 68"/>
+          <p:cNvPr id="102" name="Text 80"/>
           <p:cNvSpPr txBox="1"/>
           <p:nvPr/>
         </p:nvSpPr>

</xml_diff>

<commit_message>
Add Payments and Fund Billing to the data-in-transit list
The center hub's data category list grows from 6 to 8 items: Orders,
Cash, Customer Info, Tax Info, Dividends, Holdings, Payments, and Fund
Billing. Header block compacted and row sizing made dynamic (based on
item count) so all eight fit cleanly within the existing box height.

Co-Authored-By: Claude Sonnet 5 <noreply@anthropic.com>
Claude-Session: https://claude.ai/code/session_01XLt1ze3JWdaihuSAsk6TrZ
</commit_message>
<xml_diff>
--- a/docs/presentations/Transfer_Agent_Data_Flow.pptx
+++ b/docs/presentations/Transfer_Agent_Data_Flow.pptx
@@ -1562,8 +1562,8 @@
         </p:nvSpPr>
         <p:spPr>
           <a:xfrm>
-            <a:off x="4960620" y="1892808"/>
-            <a:ext cx="548640" cy="548640"/>
+            <a:off x="4988052" y="1837944"/>
+            <a:ext cx="493776" cy="493776"/>
           </a:xfrm>
           <a:prstGeom prst="ellipse">
             <a:avLst/>
@@ -1590,8 +1590,8 @@
         </p:blipFill>
         <p:spPr>
           <a:xfrm>
-            <a:off x="5103266" y="2035454"/>
-            <a:ext cx="263347" cy="263347"/>
+            <a:off x="5116434" y="1966326"/>
+            <a:ext cx="237012" cy="237012"/>
           </a:xfrm>
           <a:prstGeom prst="rect">
             <a:avLst/>
@@ -1606,8 +1606,8 @@
         </p:nvSpPr>
         <p:spPr>
           <a:xfrm>
-            <a:off x="4297680" y="2532888"/>
-            <a:ext cx="1874520" cy="365760"/>
+            <a:off x="4297680" y="2368296"/>
+            <a:ext cx="1874520" cy="310896"/>
           </a:xfrm>
           <a:prstGeom prst="rect">
             <a:avLst/>
@@ -1623,7 +1623,7 @@
               <a:buNone/>
             </a:pPr>
             <a:r>
-              <a:rPr lang="en-US" sz="1600" b="1" dirty="0">
+              <a:rPr lang="en-US" sz="1450" b="1" dirty="0">
                 <a:solidFill>
                   <a:srgbClr val="FFFFFF"/>
                 </a:solidFill>
@@ -1633,7 +1633,7 @@
               </a:rPr>
               <a:t>TRANSFER AGENT</a:t>
             </a:r>
-            <a:endParaRPr lang="en-US" sz="1600" dirty="0"/>
+            <a:endParaRPr lang="en-US" sz="1450" dirty="0"/>
           </a:p>
         </p:txBody>
       </p:sp>
@@ -1645,8 +1645,8 @@
         </p:nvSpPr>
         <p:spPr>
           <a:xfrm>
-            <a:off x="4297680" y="2898648"/>
-            <a:ext cx="1874520" cy="256032"/>
+            <a:off x="4297680" y="2679192"/>
+            <a:ext cx="1874520" cy="219456"/>
           </a:xfrm>
           <a:prstGeom prst="rect">
             <a:avLst/>
@@ -1662,7 +1662,7 @@
               <a:buNone/>
             </a:pPr>
             <a:r>
-              <a:rPr lang="en-US" sz="1050" i="1" dirty="0">
+              <a:rPr lang="en-US" sz="1000" i="1" dirty="0">
                 <a:solidFill>
                   <a:srgbClr val="C89B3C"/>
                 </a:solidFill>
@@ -1672,7 +1672,7 @@
               </a:rPr>
               <a:t>Data Flow Hub</a:t>
             </a:r>
-            <a:endParaRPr lang="en-US" sz="1050" dirty="0"/>
+            <a:endParaRPr lang="en-US" sz="1000" dirty="0"/>
           </a:p>
         </p:txBody>
       </p:sp>
@@ -1684,7 +1684,7 @@
         </p:nvSpPr>
         <p:spPr>
           <a:xfrm>
-            <a:off x="4526280" y="3264408"/>
+            <a:off x="4526280" y="2990088"/>
             <a:ext cx="1417320" cy="0"/>
           </a:xfrm>
           <a:prstGeom prst="line">
@@ -1707,8 +1707,8 @@
         </p:nvSpPr>
         <p:spPr>
           <a:xfrm>
-            <a:off x="4297680" y="3337560"/>
-            <a:ext cx="1874520" cy="219456"/>
+            <a:off x="4297680" y="3044952"/>
+            <a:ext cx="1874520" cy="201168"/>
           </a:xfrm>
           <a:prstGeom prst="rect">
             <a:avLst/>
@@ -1724,7 +1724,7 @@
               <a:buNone/>
             </a:pPr>
             <a:r>
-              <a:rPr lang="en-US" sz="900" b="1" spc="150" kern="0" dirty="0">
+              <a:rPr lang="en-US" sz="850" b="1" spc="130" kern="0" dirty="0">
                 <a:solidFill>
                   <a:srgbClr val="8891B3"/>
                 </a:solidFill>
@@ -1734,7 +1734,7 @@
               </a:rPr>
               <a:t>DATA IN TRANSIT</a:t>
             </a:r>
-            <a:endParaRPr lang="en-US" sz="900" dirty="0"/>
+            <a:endParaRPr lang="en-US" sz="850" dirty="0"/>
           </a:p>
         </p:txBody>
       </p:sp>
@@ -1746,8 +1746,8 @@
         </p:nvSpPr>
         <p:spPr>
           <a:xfrm>
-            <a:off x="4361688" y="3680460"/>
-            <a:ext cx="274320" cy="274320"/>
+            <a:off x="4361688" y="3345561"/>
+            <a:ext cx="246888" cy="246888"/>
           </a:xfrm>
           <a:prstGeom prst="ellipse">
             <a:avLst/>
@@ -1774,8 +1774,8 @@
         </p:blipFill>
         <p:spPr>
           <a:xfrm>
-            <a:off x="4433011" y="3751783"/>
-            <a:ext cx="131674" cy="131674"/>
+            <a:off x="4425879" y="3409752"/>
+            <a:ext cx="118506" cy="118506"/>
           </a:xfrm>
           <a:prstGeom prst="rect">
             <a:avLst/>
@@ -1790,8 +1790,8 @@
         </p:nvSpPr>
         <p:spPr>
           <a:xfrm>
-            <a:off x="4764024" y="3648456"/>
-            <a:ext cx="1408176" cy="338328"/>
+            <a:off x="4727448" y="3319272"/>
+            <a:ext cx="1453896" cy="299466"/>
           </a:xfrm>
           <a:prstGeom prst="rect">
             <a:avLst/>
@@ -1807,7 +1807,7 @@
               <a:buNone/>
             </a:pPr>
             <a:r>
-              <a:rPr lang="en-US" sz="1150" b="1" dirty="0">
+              <a:rPr lang="en-US" sz="1050" b="1" dirty="0">
                 <a:solidFill>
                   <a:srgbClr val="CADCFC"/>
                 </a:solidFill>
@@ -1817,7 +1817,7 @@
               </a:rPr>
               <a:t>Orders</a:t>
             </a:r>
-            <a:endParaRPr lang="en-US" sz="1150" dirty="0"/>
+            <a:endParaRPr lang="en-US" sz="1050" dirty="0"/>
           </a:p>
         </p:txBody>
       </p:sp>
@@ -1829,8 +1829,8 @@
         </p:nvSpPr>
         <p:spPr>
           <a:xfrm>
-            <a:off x="4361688" y="4055364"/>
-            <a:ext cx="274320" cy="274320"/>
+            <a:off x="4361688" y="3672459"/>
+            <a:ext cx="246888" cy="246888"/>
           </a:xfrm>
           <a:prstGeom prst="ellipse">
             <a:avLst/>
@@ -1857,8 +1857,8 @@
         </p:blipFill>
         <p:spPr>
           <a:xfrm>
-            <a:off x="4433011" y="4126687"/>
-            <a:ext cx="131674" cy="131674"/>
+            <a:off x="4425879" y="3736650"/>
+            <a:ext cx="118506" cy="118506"/>
           </a:xfrm>
           <a:prstGeom prst="rect">
             <a:avLst/>
@@ -1873,8 +1873,8 @@
         </p:nvSpPr>
         <p:spPr>
           <a:xfrm>
-            <a:off x="4764024" y="4023360"/>
-            <a:ext cx="1408176" cy="338328"/>
+            <a:off x="4727448" y="3646170"/>
+            <a:ext cx="1453896" cy="299466"/>
           </a:xfrm>
           <a:prstGeom prst="rect">
             <a:avLst/>
@@ -1890,7 +1890,7 @@
               <a:buNone/>
             </a:pPr>
             <a:r>
-              <a:rPr lang="en-US" sz="1150" b="1" dirty="0">
+              <a:rPr lang="en-US" sz="1050" b="1" dirty="0">
                 <a:solidFill>
                   <a:srgbClr val="CADCFC"/>
                 </a:solidFill>
@@ -1900,7 +1900,7 @@
               </a:rPr>
               <a:t>Cash</a:t>
             </a:r>
-            <a:endParaRPr lang="en-US" sz="1150" dirty="0"/>
+            <a:endParaRPr lang="en-US" sz="1050" dirty="0"/>
           </a:p>
         </p:txBody>
       </p:sp>
@@ -1912,8 +1912,8 @@
         </p:nvSpPr>
         <p:spPr>
           <a:xfrm>
-            <a:off x="4361688" y="4430268"/>
-            <a:ext cx="274320" cy="274320"/>
+            <a:off x="4361688" y="3999357"/>
+            <a:ext cx="246888" cy="246888"/>
           </a:xfrm>
           <a:prstGeom prst="ellipse">
             <a:avLst/>
@@ -1940,8 +1940,8 @@
         </p:blipFill>
         <p:spPr>
           <a:xfrm>
-            <a:off x="4433011" y="4501591"/>
-            <a:ext cx="131674" cy="131674"/>
+            <a:off x="4425879" y="4063548"/>
+            <a:ext cx="118506" cy="118506"/>
           </a:xfrm>
           <a:prstGeom prst="rect">
             <a:avLst/>
@@ -1956,8 +1956,8 @@
         </p:nvSpPr>
         <p:spPr>
           <a:xfrm>
-            <a:off x="4764024" y="4398264"/>
-            <a:ext cx="1408176" cy="338328"/>
+            <a:off x="4727448" y="3973068"/>
+            <a:ext cx="1453896" cy="299466"/>
           </a:xfrm>
           <a:prstGeom prst="rect">
             <a:avLst/>
@@ -1973,7 +1973,7 @@
               <a:buNone/>
             </a:pPr>
             <a:r>
-              <a:rPr lang="en-US" sz="1150" b="1" dirty="0">
+              <a:rPr lang="en-US" sz="1050" b="1" dirty="0">
                 <a:solidFill>
                   <a:srgbClr val="CADCFC"/>
                 </a:solidFill>
@@ -1983,7 +1983,7 @@
               </a:rPr>
               <a:t>Customer Info</a:t>
             </a:r>
-            <a:endParaRPr lang="en-US" sz="1150" dirty="0"/>
+            <a:endParaRPr lang="en-US" sz="1050" dirty="0"/>
           </a:p>
         </p:txBody>
       </p:sp>
@@ -1995,8 +1995,8 @@
         </p:nvSpPr>
         <p:spPr>
           <a:xfrm>
-            <a:off x="4361688" y="4805172"/>
-            <a:ext cx="274320" cy="274320"/>
+            <a:off x="4361688" y="4326255"/>
+            <a:ext cx="246888" cy="246888"/>
           </a:xfrm>
           <a:prstGeom prst="ellipse">
             <a:avLst/>
@@ -2023,8 +2023,8 @@
         </p:blipFill>
         <p:spPr>
           <a:xfrm>
-            <a:off x="4433011" y="4876495"/>
-            <a:ext cx="131674" cy="131674"/>
+            <a:off x="4425879" y="4390446"/>
+            <a:ext cx="118506" cy="118506"/>
           </a:xfrm>
           <a:prstGeom prst="rect">
             <a:avLst/>
@@ -2039,8 +2039,8 @@
         </p:nvSpPr>
         <p:spPr>
           <a:xfrm>
-            <a:off x="4764024" y="4773168"/>
-            <a:ext cx="1408176" cy="338328"/>
+            <a:off x="4727448" y="4299966"/>
+            <a:ext cx="1453896" cy="299466"/>
           </a:xfrm>
           <a:prstGeom prst="rect">
             <a:avLst/>
@@ -2056,7 +2056,7 @@
               <a:buNone/>
             </a:pPr>
             <a:r>
-              <a:rPr lang="en-US" sz="1150" b="1" dirty="0">
+              <a:rPr lang="en-US" sz="1050" b="1" dirty="0">
                 <a:solidFill>
                   <a:srgbClr val="CADCFC"/>
                 </a:solidFill>
@@ -2066,7 +2066,7 @@
               </a:rPr>
               <a:t>Tax Info</a:t>
             </a:r>
-            <a:endParaRPr lang="en-US" sz="1150" dirty="0"/>
+            <a:endParaRPr lang="en-US" sz="1050" dirty="0"/>
           </a:p>
         </p:txBody>
       </p:sp>
@@ -2078,8 +2078,8 @@
         </p:nvSpPr>
         <p:spPr>
           <a:xfrm>
-            <a:off x="4361688" y="5180076"/>
-            <a:ext cx="274320" cy="274320"/>
+            <a:off x="4361688" y="4653153"/>
+            <a:ext cx="246888" cy="246888"/>
           </a:xfrm>
           <a:prstGeom prst="ellipse">
             <a:avLst/>
@@ -2106,8 +2106,8 @@
         </p:blipFill>
         <p:spPr>
           <a:xfrm>
-            <a:off x="4433011" y="5251399"/>
-            <a:ext cx="131674" cy="131674"/>
+            <a:off x="4425879" y="4717344"/>
+            <a:ext cx="118506" cy="118506"/>
           </a:xfrm>
           <a:prstGeom prst="rect">
             <a:avLst/>
@@ -2122,8 +2122,8 @@
         </p:nvSpPr>
         <p:spPr>
           <a:xfrm>
-            <a:off x="4764024" y="5148072"/>
-            <a:ext cx="1408176" cy="338328"/>
+            <a:off x="4727448" y="4626864"/>
+            <a:ext cx="1453896" cy="299466"/>
           </a:xfrm>
           <a:prstGeom prst="rect">
             <a:avLst/>
@@ -2139,7 +2139,7 @@
               <a:buNone/>
             </a:pPr>
             <a:r>
-              <a:rPr lang="en-US" sz="1150" b="1" dirty="0">
+              <a:rPr lang="en-US" sz="1050" b="1" dirty="0">
                 <a:solidFill>
                   <a:srgbClr val="CADCFC"/>
                 </a:solidFill>
@@ -2149,7 +2149,7 @@
               </a:rPr>
               <a:t>Dividends</a:t>
             </a:r>
-            <a:endParaRPr lang="en-US" sz="1150" dirty="0"/>
+            <a:endParaRPr lang="en-US" sz="1050" dirty="0"/>
           </a:p>
         </p:txBody>
       </p:sp>
@@ -2161,8 +2161,8 @@
         </p:nvSpPr>
         <p:spPr>
           <a:xfrm>
-            <a:off x="4361688" y="5554980"/>
-            <a:ext cx="274320" cy="274320"/>
+            <a:off x="4361688" y="4980051"/>
+            <a:ext cx="246888" cy="246888"/>
           </a:xfrm>
           <a:prstGeom prst="ellipse">
             <a:avLst/>
@@ -2189,8 +2189,8 @@
         </p:blipFill>
         <p:spPr>
           <a:xfrm>
-            <a:off x="4433011" y="5626303"/>
-            <a:ext cx="131674" cy="131674"/>
+            <a:off x="4425879" y="5044242"/>
+            <a:ext cx="118506" cy="118506"/>
           </a:xfrm>
           <a:prstGeom prst="rect">
             <a:avLst/>
@@ -2205,8 +2205,8 @@
         </p:nvSpPr>
         <p:spPr>
           <a:xfrm>
-            <a:off x="4764024" y="5522976"/>
-            <a:ext cx="1408176" cy="338328"/>
+            <a:off x="4727448" y="4953762"/>
+            <a:ext cx="1453896" cy="299466"/>
           </a:xfrm>
           <a:prstGeom prst="rect">
             <a:avLst/>
@@ -2222,7 +2222,7 @@
               <a:buNone/>
             </a:pPr>
             <a:r>
-              <a:rPr lang="en-US" sz="1150" b="1" dirty="0">
+              <a:rPr lang="en-US" sz="1050" b="1" dirty="0">
                 <a:solidFill>
                   <a:srgbClr val="CADCFC"/>
                 </a:solidFill>
@@ -2232,13 +2232,179 @@
               </a:rPr>
               <a:t>Holdings</a:t>
             </a:r>
-            <a:endParaRPr lang="en-US" sz="1150" dirty="0"/>
+            <a:endParaRPr lang="en-US" sz="1050" dirty="0"/>
           </a:p>
         </p:txBody>
       </p:sp>
       <p:sp>
         <p:nvSpPr>
           <p:cNvPr id="35" name="Shape 26"/>
+          <p:cNvSpPr/>
+          <p:nvPr/>
+        </p:nvSpPr>
+        <p:spPr>
+          <a:xfrm>
+            <a:off x="4361688" y="5306949"/>
+            <a:ext cx="246888" cy="246888"/>
+          </a:xfrm>
+          <a:prstGeom prst="ellipse">
+            <a:avLst/>
+          </a:prstGeom>
+          <a:solidFill>
+            <a:srgbClr val="3A4694"/>
+          </a:solidFill>
+          <a:ln/>
+        </p:spPr>
+      </p:sp>
+      <p:pic>
+        <p:nvPicPr>
+          <p:cNvPr id="36" name="Image 7" descr="preencoded.png">    </p:cNvPr>
+          <p:cNvPicPr>
+            <a:picLocks noChangeAspect="1"/>
+          </p:cNvPicPr>
+          <p:nvPr/>
+        </p:nvPicPr>
+        <p:blipFill>
+          <a:blip r:embed="rId8"/>
+          <a:stretch>
+            <a:fillRect/>
+          </a:stretch>
+        </p:blipFill>
+        <p:spPr>
+          <a:xfrm>
+            <a:off x="4425879" y="5371140"/>
+            <a:ext cx="118506" cy="118506"/>
+          </a:xfrm>
+          <a:prstGeom prst="rect">
+            <a:avLst/>
+          </a:prstGeom>
+        </p:spPr>
+      </p:pic>
+      <p:sp>
+        <p:nvSpPr>
+          <p:cNvPr id="37" name="Text 27"/>
+          <p:cNvSpPr txBox="1"/>
+          <p:nvPr/>
+        </p:nvSpPr>
+        <p:spPr>
+          <a:xfrm>
+            <a:off x="4727448" y="5280660"/>
+            <a:ext cx="1453896" cy="299466"/>
+          </a:xfrm>
+          <a:prstGeom prst="rect">
+            <a:avLst/>
+          </a:prstGeom>
+          <a:noFill/>
+          <a:ln/>
+        </p:spPr>
+        <p:txBody>
+          <a:bodyPr wrap="square" lIns="0" tIns="0" rIns="0" bIns="0" rtlCol="0" anchor="ctr"/>
+          <a:lstStyle/>
+          <a:p>
+            <a:pPr algn="l" indent="0" marL="0">
+              <a:buNone/>
+            </a:pPr>
+            <a:r>
+              <a:rPr lang="en-US" sz="1050" b="1" dirty="0">
+                <a:solidFill>
+                  <a:srgbClr val="CADCFC"/>
+                </a:solidFill>
+                <a:latin typeface="Calibri" pitchFamily="34" charset="0"/>
+                <a:ea typeface="Calibri" pitchFamily="34" charset="-122"/>
+                <a:cs typeface="Calibri" pitchFamily="34" charset="-120"/>
+              </a:rPr>
+              <a:t>Payments</a:t>
+            </a:r>
+            <a:endParaRPr lang="en-US" sz="1050" dirty="0"/>
+          </a:p>
+        </p:txBody>
+      </p:sp>
+      <p:sp>
+        <p:nvSpPr>
+          <p:cNvPr id="38" name="Shape 28"/>
+          <p:cNvSpPr/>
+          <p:nvPr/>
+        </p:nvSpPr>
+        <p:spPr>
+          <a:xfrm>
+            <a:off x="4361688" y="5633847"/>
+            <a:ext cx="246888" cy="246888"/>
+          </a:xfrm>
+          <a:prstGeom prst="ellipse">
+            <a:avLst/>
+          </a:prstGeom>
+          <a:solidFill>
+            <a:srgbClr val="3A4694"/>
+          </a:solidFill>
+          <a:ln/>
+        </p:spPr>
+      </p:sp>
+      <p:pic>
+        <p:nvPicPr>
+          <p:cNvPr id="39" name="Image 8" descr="preencoded.png">    </p:cNvPr>
+          <p:cNvPicPr>
+            <a:picLocks noChangeAspect="1"/>
+          </p:cNvPicPr>
+          <p:nvPr/>
+        </p:nvPicPr>
+        <p:blipFill>
+          <a:blip r:embed="rId9"/>
+          <a:stretch>
+            <a:fillRect/>
+          </a:stretch>
+        </p:blipFill>
+        <p:spPr>
+          <a:xfrm>
+            <a:off x="4425879" y="5698038"/>
+            <a:ext cx="118506" cy="118506"/>
+          </a:xfrm>
+          <a:prstGeom prst="rect">
+            <a:avLst/>
+          </a:prstGeom>
+        </p:spPr>
+      </p:pic>
+      <p:sp>
+        <p:nvSpPr>
+          <p:cNvPr id="40" name="Text 29"/>
+          <p:cNvSpPr txBox="1"/>
+          <p:nvPr/>
+        </p:nvSpPr>
+        <p:spPr>
+          <a:xfrm>
+            <a:off x="4727448" y="5607558"/>
+            <a:ext cx="1453896" cy="299466"/>
+          </a:xfrm>
+          <a:prstGeom prst="rect">
+            <a:avLst/>
+          </a:prstGeom>
+          <a:noFill/>
+          <a:ln/>
+        </p:spPr>
+        <p:txBody>
+          <a:bodyPr wrap="square" lIns="0" tIns="0" rIns="0" bIns="0" rtlCol="0" anchor="ctr"/>
+          <a:lstStyle/>
+          <a:p>
+            <a:pPr algn="l" indent="0" marL="0">
+              <a:buNone/>
+            </a:pPr>
+            <a:r>
+              <a:rPr lang="en-US" sz="1050" b="1" dirty="0">
+                <a:solidFill>
+                  <a:srgbClr val="CADCFC"/>
+                </a:solidFill>
+                <a:latin typeface="Calibri" pitchFamily="34" charset="0"/>
+                <a:ea typeface="Calibri" pitchFamily="34" charset="-122"/>
+                <a:cs typeface="Calibri" pitchFamily="34" charset="-120"/>
+              </a:rPr>
+              <a:t>Fund Billing</a:t>
+            </a:r>
+            <a:endParaRPr lang="en-US" sz="1050" dirty="0"/>
+          </a:p>
+        </p:txBody>
+      </p:sp>
+      <p:sp>
+        <p:nvSpPr>
+          <p:cNvPr id="41" name="Shape 30"/>
           <p:cNvSpPr/>
           <p:nvPr/>
         </p:nvSpPr>
@@ -2263,7 +2429,7 @@
       </p:sp>
       <p:sp>
         <p:nvSpPr>
-          <p:cNvPr id="36" name="Shape 27"/>
+          <p:cNvPr id="42" name="Shape 31"/>
           <p:cNvSpPr/>
           <p:nvPr/>
         </p:nvSpPr>
@@ -2288,7 +2454,7 @@
       </p:sp>
       <p:sp>
         <p:nvSpPr>
-          <p:cNvPr id="37" name="Shape 28"/>
+          <p:cNvPr id="43" name="Shape 32"/>
           <p:cNvSpPr/>
           <p:nvPr/>
         </p:nvSpPr>
@@ -2313,7 +2479,7 @@
       </p:sp>
       <p:sp>
         <p:nvSpPr>
-          <p:cNvPr id="38" name="Shape 29"/>
+          <p:cNvPr id="44" name="Shape 33"/>
           <p:cNvSpPr/>
           <p:nvPr/>
         </p:nvSpPr>
@@ -2338,7 +2504,7 @@
       </p:sp>
       <p:sp>
         <p:nvSpPr>
-          <p:cNvPr id="39" name="Shape 30"/>
+          <p:cNvPr id="45" name="Shape 34"/>
           <p:cNvSpPr/>
           <p:nvPr/>
         </p:nvSpPr>
@@ -2363,7 +2529,7 @@
       </p:sp>
       <p:sp>
         <p:nvSpPr>
-          <p:cNvPr id="40" name="Shape 31"/>
+          <p:cNvPr id="46" name="Shape 35"/>
           <p:cNvSpPr/>
           <p:nvPr/>
         </p:nvSpPr>
@@ -2387,7 +2553,7 @@
       </p:sp>
       <p:sp>
         <p:nvSpPr>
-          <p:cNvPr id="41" name="Shape 32"/>
+          <p:cNvPr id="47" name="Shape 36"/>
           <p:cNvSpPr/>
           <p:nvPr/>
         </p:nvSpPr>
@@ -2412,7 +2578,7 @@
       </p:sp>
       <p:sp>
         <p:nvSpPr>
-          <p:cNvPr id="42" name="Shape 33"/>
+          <p:cNvPr id="48" name="Shape 37"/>
           <p:cNvSpPr/>
           <p:nvPr/>
         </p:nvSpPr>
@@ -2437,7 +2603,7 @@
       </p:sp>
       <p:sp>
         <p:nvSpPr>
-          <p:cNvPr id="43" name="Shape 34"/>
+          <p:cNvPr id="49" name="Shape 38"/>
           <p:cNvSpPr/>
           <p:nvPr/>
         </p:nvSpPr>
@@ -2461,7 +2627,7 @@
       </p:sp>
       <p:sp>
         <p:nvSpPr>
-          <p:cNvPr id="44" name="Shape 35"/>
+          <p:cNvPr id="50" name="Shape 39"/>
           <p:cNvSpPr/>
           <p:nvPr/>
         </p:nvSpPr>
@@ -2485,7 +2651,7 @@
       </p:sp>
       <p:sp>
         <p:nvSpPr>
-          <p:cNvPr id="45" name="Shape 36"/>
+          <p:cNvPr id="51" name="Shape 40"/>
           <p:cNvSpPr/>
           <p:nvPr/>
         </p:nvSpPr>
@@ -2510,7 +2676,7 @@
       </p:sp>
       <p:sp>
         <p:nvSpPr>
-          <p:cNvPr id="46" name="Shape 37"/>
+          <p:cNvPr id="52" name="Shape 41"/>
           <p:cNvSpPr/>
           <p:nvPr/>
         </p:nvSpPr>
@@ -2534,7 +2700,7 @@
       </p:sp>
       <p:sp>
         <p:nvSpPr>
-          <p:cNvPr id="47" name="Shape 38"/>
+          <p:cNvPr id="53" name="Shape 42"/>
           <p:cNvSpPr/>
           <p:nvPr/>
         </p:nvSpPr>
@@ -2558,7 +2724,7 @@
       </p:sp>
       <p:sp>
         <p:nvSpPr>
-          <p:cNvPr id="48" name="Shape 39"/>
+          <p:cNvPr id="54" name="Shape 43"/>
           <p:cNvSpPr/>
           <p:nvPr/>
         </p:nvSpPr>
@@ -2592,7 +2758,7 @@
       </p:sp>
       <p:sp>
         <p:nvSpPr>
-          <p:cNvPr id="49" name="Shape 40"/>
+          <p:cNvPr id="55" name="Shape 44"/>
           <p:cNvSpPr/>
           <p:nvPr/>
         </p:nvSpPr>
@@ -2612,14 +2778,14 @@
       </p:sp>
       <p:pic>
         <p:nvPicPr>
-          <p:cNvPr id="50" name="Image 7" descr="preencoded.png">    </p:cNvPr>
+          <p:cNvPr id="56" name="Image 9" descr="preencoded.png">    </p:cNvPr>
           <p:cNvPicPr>
             <a:picLocks noChangeAspect="1"/>
           </p:cNvPicPr>
           <p:nvPr/>
         </p:nvPicPr>
         <p:blipFill>
-          <a:blip r:embed="rId8"/>
+          <a:blip r:embed="rId10"/>
           <a:stretch>
             <a:fillRect/>
           </a:stretch>
@@ -2636,7 +2802,7 @@
       </p:pic>
       <p:sp>
         <p:nvSpPr>
-          <p:cNvPr id="51" name="Text 41"/>
+          <p:cNvPr id="57" name="Text 45"/>
           <p:cNvSpPr txBox="1"/>
           <p:nvPr/>
         </p:nvSpPr>
@@ -2698,7 +2864,7 @@
       </p:sp>
       <p:sp>
         <p:nvSpPr>
-          <p:cNvPr id="52" name="Shape 42"/>
+          <p:cNvPr id="58" name="Shape 46"/>
           <p:cNvSpPr/>
           <p:nvPr/>
         </p:nvSpPr>
@@ -2732,7 +2898,7 @@
       </p:sp>
       <p:sp>
         <p:nvSpPr>
-          <p:cNvPr id="53" name="Shape 43"/>
+          <p:cNvPr id="59" name="Shape 47"/>
           <p:cNvSpPr/>
           <p:nvPr/>
         </p:nvSpPr>
@@ -2752,14 +2918,14 @@
       </p:sp>
       <p:pic>
         <p:nvPicPr>
-          <p:cNvPr id="54" name="Image 8" descr="preencoded.png">    </p:cNvPr>
+          <p:cNvPr id="60" name="Image 10" descr="preencoded.png">    </p:cNvPr>
           <p:cNvPicPr>
             <a:picLocks noChangeAspect="1"/>
           </p:cNvPicPr>
           <p:nvPr/>
         </p:nvPicPr>
         <p:blipFill>
-          <a:blip r:embed="rId9"/>
+          <a:blip r:embed="rId11"/>
           <a:stretch>
             <a:fillRect/>
           </a:stretch>
@@ -2776,7 +2942,7 @@
       </p:pic>
       <p:sp>
         <p:nvSpPr>
-          <p:cNvPr id="55" name="Text 44"/>
+          <p:cNvPr id="61" name="Text 48"/>
           <p:cNvSpPr txBox="1"/>
           <p:nvPr/>
         </p:nvSpPr>
@@ -2838,7 +3004,7 @@
       </p:sp>
       <p:sp>
         <p:nvSpPr>
-          <p:cNvPr id="56" name="Shape 45"/>
+          <p:cNvPr id="62" name="Shape 49"/>
           <p:cNvSpPr/>
           <p:nvPr/>
         </p:nvSpPr>
@@ -2872,7 +3038,7 @@
       </p:sp>
       <p:sp>
         <p:nvSpPr>
-          <p:cNvPr id="57" name="Shape 46"/>
+          <p:cNvPr id="63" name="Shape 50"/>
           <p:cNvSpPr/>
           <p:nvPr/>
         </p:nvSpPr>
@@ -2892,14 +3058,14 @@
       </p:sp>
       <p:pic>
         <p:nvPicPr>
-          <p:cNvPr id="58" name="Image 9" descr="preencoded.png">    </p:cNvPr>
+          <p:cNvPr id="64" name="Image 11" descr="preencoded.png">    </p:cNvPr>
           <p:cNvPicPr>
             <a:picLocks noChangeAspect="1"/>
           </p:cNvPicPr>
           <p:nvPr/>
         </p:nvPicPr>
         <p:blipFill>
-          <a:blip r:embed="rId10"/>
+          <a:blip r:embed="rId12"/>
           <a:stretch>
             <a:fillRect/>
           </a:stretch>
@@ -2916,7 +3082,7 @@
       </p:pic>
       <p:sp>
         <p:nvSpPr>
-          <p:cNvPr id="59" name="Text 47"/>
+          <p:cNvPr id="65" name="Text 51"/>
           <p:cNvSpPr txBox="1"/>
           <p:nvPr/>
         </p:nvSpPr>
@@ -2978,7 +3144,7 @@
       </p:sp>
       <p:sp>
         <p:nvSpPr>
-          <p:cNvPr id="60" name="Shape 48"/>
+          <p:cNvPr id="66" name="Shape 52"/>
           <p:cNvSpPr/>
           <p:nvPr/>
         </p:nvSpPr>
@@ -3012,7 +3178,7 @@
       </p:sp>
       <p:sp>
         <p:nvSpPr>
-          <p:cNvPr id="61" name="Shape 49"/>
+          <p:cNvPr id="67" name="Shape 53"/>
           <p:cNvSpPr/>
           <p:nvPr/>
         </p:nvSpPr>
@@ -3032,14 +3198,14 @@
       </p:sp>
       <p:pic>
         <p:nvPicPr>
-          <p:cNvPr id="62" name="Image 10" descr="preencoded.png">    </p:cNvPr>
+          <p:cNvPr id="68" name="Image 12" descr="preencoded.png">    </p:cNvPr>
           <p:cNvPicPr>
             <a:picLocks noChangeAspect="1"/>
           </p:cNvPicPr>
           <p:nvPr/>
         </p:nvPicPr>
         <p:blipFill>
-          <a:blip r:embed="rId11"/>
+          <a:blip r:embed="rId13"/>
           <a:stretch>
             <a:fillRect/>
           </a:stretch>
@@ -3056,7 +3222,7 @@
       </p:pic>
       <p:sp>
         <p:nvSpPr>
-          <p:cNvPr id="63" name="Text 50"/>
+          <p:cNvPr id="69" name="Text 54"/>
           <p:cNvSpPr txBox="1"/>
           <p:nvPr/>
         </p:nvSpPr>
@@ -3118,7 +3284,7 @@
       </p:sp>
       <p:sp>
         <p:nvSpPr>
-          <p:cNvPr id="64" name="Shape 51"/>
+          <p:cNvPr id="70" name="Shape 55"/>
           <p:cNvSpPr/>
           <p:nvPr/>
         </p:nvSpPr>
@@ -3152,7 +3318,7 @@
       </p:sp>
       <p:sp>
         <p:nvSpPr>
-          <p:cNvPr id="65" name="Shape 52"/>
+          <p:cNvPr id="71" name="Shape 56"/>
           <p:cNvSpPr/>
           <p:nvPr/>
         </p:nvSpPr>
@@ -3172,14 +3338,14 @@
       </p:sp>
       <p:pic>
         <p:nvPicPr>
-          <p:cNvPr id="66" name="Image 11" descr="preencoded.png">    </p:cNvPr>
+          <p:cNvPr id="72" name="Image 13" descr="preencoded.png">    </p:cNvPr>
           <p:cNvPicPr>
             <a:picLocks noChangeAspect="1"/>
           </p:cNvPicPr>
           <p:nvPr/>
         </p:nvPicPr>
         <p:blipFill>
-          <a:blip r:embed="rId12"/>
+          <a:blip r:embed="rId14"/>
           <a:stretch>
             <a:fillRect/>
           </a:stretch>
@@ -3196,7 +3362,7 @@
       </p:pic>
       <p:sp>
         <p:nvSpPr>
-          <p:cNvPr id="67" name="Text 53"/>
+          <p:cNvPr id="73" name="Text 57"/>
           <p:cNvSpPr txBox="1"/>
           <p:nvPr/>
         </p:nvSpPr>
@@ -3238,7 +3404,7 @@
       </p:sp>
       <p:sp>
         <p:nvSpPr>
-          <p:cNvPr id="68" name="Shape 54"/>
+          <p:cNvPr id="74" name="Shape 58"/>
           <p:cNvSpPr/>
           <p:nvPr/>
         </p:nvSpPr>
@@ -3272,7 +3438,7 @@
       </p:sp>
       <p:sp>
         <p:nvSpPr>
-          <p:cNvPr id="69" name="Shape 55"/>
+          <p:cNvPr id="75" name="Shape 59"/>
           <p:cNvSpPr/>
           <p:nvPr/>
         </p:nvSpPr>
@@ -3292,14 +3458,14 @@
       </p:sp>
       <p:pic>
         <p:nvPicPr>
-          <p:cNvPr id="70" name="Image 12" descr="preencoded.png">    </p:cNvPr>
+          <p:cNvPr id="76" name="Image 14" descr="preencoded.png">    </p:cNvPr>
           <p:cNvPicPr>
             <a:picLocks noChangeAspect="1"/>
           </p:cNvPicPr>
           <p:nvPr/>
         </p:nvPicPr>
         <p:blipFill>
-          <a:blip r:embed="rId13"/>
+          <a:blip r:embed="rId15"/>
           <a:stretch>
             <a:fillRect/>
           </a:stretch>
@@ -3316,7 +3482,7 @@
       </p:pic>
       <p:sp>
         <p:nvSpPr>
-          <p:cNvPr id="71" name="Text 56"/>
+          <p:cNvPr id="77" name="Text 60"/>
           <p:cNvSpPr txBox="1"/>
           <p:nvPr/>
         </p:nvSpPr>
@@ -3378,7 +3544,7 @@
       </p:sp>
       <p:sp>
         <p:nvSpPr>
-          <p:cNvPr id="72" name="Shape 57"/>
+          <p:cNvPr id="78" name="Shape 61"/>
           <p:cNvSpPr/>
           <p:nvPr/>
         </p:nvSpPr>
@@ -3412,7 +3578,7 @@
       </p:sp>
       <p:sp>
         <p:nvSpPr>
-          <p:cNvPr id="73" name="Shape 58"/>
+          <p:cNvPr id="79" name="Shape 62"/>
           <p:cNvSpPr/>
           <p:nvPr/>
         </p:nvSpPr>
@@ -3432,14 +3598,14 @@
       </p:sp>
       <p:pic>
         <p:nvPicPr>
-          <p:cNvPr id="74" name="Image 13" descr="preencoded.png">    </p:cNvPr>
+          <p:cNvPr id="80" name="Image 15" descr="preencoded.png">    </p:cNvPr>
           <p:cNvPicPr>
             <a:picLocks noChangeAspect="1"/>
           </p:cNvPicPr>
           <p:nvPr/>
         </p:nvPicPr>
         <p:blipFill>
-          <a:blip r:embed="rId14"/>
+          <a:blip r:embed="rId16"/>
           <a:stretch>
             <a:fillRect/>
           </a:stretch>
@@ -3456,7 +3622,7 @@
       </p:pic>
       <p:sp>
         <p:nvSpPr>
-          <p:cNvPr id="75" name="Text 59"/>
+          <p:cNvPr id="81" name="Text 63"/>
           <p:cNvSpPr txBox="1"/>
           <p:nvPr/>
         </p:nvSpPr>
@@ -3498,7 +3664,7 @@
       </p:sp>
       <p:sp>
         <p:nvSpPr>
-          <p:cNvPr id="76" name="Shape 60"/>
+          <p:cNvPr id="82" name="Shape 64"/>
           <p:cNvSpPr/>
           <p:nvPr/>
         </p:nvSpPr>
@@ -3532,7 +3698,7 @@
       </p:sp>
       <p:sp>
         <p:nvSpPr>
-          <p:cNvPr id="77" name="Shape 61"/>
+          <p:cNvPr id="83" name="Shape 65"/>
           <p:cNvSpPr/>
           <p:nvPr/>
         </p:nvSpPr>
@@ -3552,14 +3718,14 @@
       </p:sp>
       <p:pic>
         <p:nvPicPr>
-          <p:cNvPr id="78" name="Image 14" descr="preencoded.png">    </p:cNvPr>
+          <p:cNvPr id="84" name="Image 16" descr="preencoded.png">    </p:cNvPr>
           <p:cNvPicPr>
             <a:picLocks noChangeAspect="1"/>
           </p:cNvPicPr>
           <p:nvPr/>
         </p:nvPicPr>
         <p:blipFill>
-          <a:blip r:embed="rId15"/>
+          <a:blip r:embed="rId17"/>
           <a:stretch>
             <a:fillRect/>
           </a:stretch>
@@ -3576,7 +3742,7 @@
       </p:pic>
       <p:sp>
         <p:nvSpPr>
-          <p:cNvPr id="79" name="Text 62"/>
+          <p:cNvPr id="85" name="Text 66"/>
           <p:cNvSpPr txBox="1"/>
           <p:nvPr/>
         </p:nvSpPr>
@@ -3618,7 +3784,7 @@
       </p:sp>
       <p:sp>
         <p:nvSpPr>
-          <p:cNvPr id="80" name="Shape 63"/>
+          <p:cNvPr id="86" name="Shape 67"/>
           <p:cNvSpPr/>
           <p:nvPr/>
         </p:nvSpPr>
@@ -3652,7 +3818,7 @@
       </p:sp>
       <p:sp>
         <p:nvSpPr>
-          <p:cNvPr id="81" name="Shape 64"/>
+          <p:cNvPr id="87" name="Shape 68"/>
           <p:cNvSpPr/>
           <p:nvPr/>
         </p:nvSpPr>
@@ -3672,14 +3838,14 @@
       </p:sp>
       <p:pic>
         <p:nvPicPr>
-          <p:cNvPr id="82" name="Image 15" descr="preencoded.png">    </p:cNvPr>
+          <p:cNvPr id="88" name="Image 17" descr="preencoded.png">    </p:cNvPr>
           <p:cNvPicPr>
             <a:picLocks noChangeAspect="1"/>
           </p:cNvPicPr>
           <p:nvPr/>
         </p:nvPicPr>
         <p:blipFill>
-          <a:blip r:embed="rId16"/>
+          <a:blip r:embed="rId18"/>
           <a:stretch>
             <a:fillRect/>
           </a:stretch>
@@ -3696,7 +3862,7 @@
       </p:pic>
       <p:sp>
         <p:nvSpPr>
-          <p:cNvPr id="83" name="Text 65"/>
+          <p:cNvPr id="89" name="Text 69"/>
           <p:cNvSpPr txBox="1"/>
           <p:nvPr/>
         </p:nvSpPr>
@@ -3738,7 +3904,7 @@
       </p:sp>
       <p:sp>
         <p:nvSpPr>
-          <p:cNvPr id="84" name="Shape 66"/>
+          <p:cNvPr id="90" name="Shape 70"/>
           <p:cNvSpPr/>
           <p:nvPr/>
         </p:nvSpPr>
@@ -3772,7 +3938,7 @@
       </p:sp>
       <p:sp>
         <p:nvSpPr>
-          <p:cNvPr id="85" name="Shape 67"/>
+          <p:cNvPr id="91" name="Shape 71"/>
           <p:cNvSpPr/>
           <p:nvPr/>
         </p:nvSpPr>
@@ -3792,14 +3958,14 @@
       </p:sp>
       <p:pic>
         <p:nvPicPr>
-          <p:cNvPr id="86" name="Image 16" descr="preencoded.png">    </p:cNvPr>
+          <p:cNvPr id="92" name="Image 18" descr="preencoded.png">    </p:cNvPr>
           <p:cNvPicPr>
             <a:picLocks noChangeAspect="1"/>
           </p:cNvPicPr>
           <p:nvPr/>
         </p:nvPicPr>
         <p:blipFill>
-          <a:blip r:embed="rId17"/>
+          <a:blip r:embed="rId19"/>
           <a:stretch>
             <a:fillRect/>
           </a:stretch>
@@ -3816,7 +3982,7 @@
       </p:pic>
       <p:sp>
         <p:nvSpPr>
-          <p:cNvPr id="87" name="Text 68"/>
+          <p:cNvPr id="93" name="Text 72"/>
           <p:cNvSpPr txBox="1"/>
           <p:nvPr/>
         </p:nvSpPr>
@@ -3858,7 +4024,7 @@
       </p:sp>
       <p:sp>
         <p:nvSpPr>
-          <p:cNvPr id="88" name="Shape 69"/>
+          <p:cNvPr id="94" name="Shape 73"/>
           <p:cNvSpPr/>
           <p:nvPr/>
         </p:nvSpPr>
@@ -3892,7 +4058,7 @@
       </p:sp>
       <p:sp>
         <p:nvSpPr>
-          <p:cNvPr id="89" name="Shape 70"/>
+          <p:cNvPr id="95" name="Shape 74"/>
           <p:cNvSpPr/>
           <p:nvPr/>
         </p:nvSpPr>
@@ -3912,14 +4078,14 @@
       </p:sp>
       <p:pic>
         <p:nvPicPr>
-          <p:cNvPr id="90" name="Image 17" descr="preencoded.png">    </p:cNvPr>
+          <p:cNvPr id="96" name="Image 19" descr="preencoded.png">    </p:cNvPr>
           <p:cNvPicPr>
             <a:picLocks noChangeAspect="1"/>
           </p:cNvPicPr>
           <p:nvPr/>
         </p:nvPicPr>
         <p:blipFill>
-          <a:blip r:embed="rId18"/>
+          <a:blip r:embed="rId20"/>
           <a:stretch>
             <a:fillRect/>
           </a:stretch>
@@ -3936,7 +4102,7 @@
       </p:pic>
       <p:sp>
         <p:nvSpPr>
-          <p:cNvPr id="91" name="Text 71"/>
+          <p:cNvPr id="97" name="Text 75"/>
           <p:cNvSpPr txBox="1"/>
           <p:nvPr/>
         </p:nvSpPr>
@@ -3998,7 +4164,7 @@
       </p:sp>
       <p:sp>
         <p:nvSpPr>
-          <p:cNvPr id="92" name="Shape 72"/>
+          <p:cNvPr id="98" name="Shape 76"/>
           <p:cNvSpPr/>
           <p:nvPr/>
         </p:nvSpPr>
@@ -4032,7 +4198,7 @@
       </p:sp>
       <p:sp>
         <p:nvSpPr>
-          <p:cNvPr id="93" name="Shape 73"/>
+          <p:cNvPr id="99" name="Shape 77"/>
           <p:cNvSpPr/>
           <p:nvPr/>
         </p:nvSpPr>
@@ -4052,14 +4218,14 @@
       </p:sp>
       <p:pic>
         <p:nvPicPr>
-          <p:cNvPr id="94" name="Image 18" descr="preencoded.png">    </p:cNvPr>
+          <p:cNvPr id="100" name="Image 20" descr="preencoded.png">    </p:cNvPr>
           <p:cNvPicPr>
             <a:picLocks noChangeAspect="1"/>
           </p:cNvPicPr>
           <p:nvPr/>
         </p:nvPicPr>
         <p:blipFill>
-          <a:blip r:embed="rId19"/>
+          <a:blip r:embed="rId21"/>
           <a:stretch>
             <a:fillRect/>
           </a:stretch>
@@ -4076,7 +4242,7 @@
       </p:pic>
       <p:sp>
         <p:nvSpPr>
-          <p:cNvPr id="95" name="Text 74"/>
+          <p:cNvPr id="101" name="Text 78"/>
           <p:cNvSpPr txBox="1"/>
           <p:nvPr/>
         </p:nvSpPr>
@@ -4138,7 +4304,7 @@
       </p:sp>
       <p:sp>
         <p:nvSpPr>
-          <p:cNvPr id="96" name="Shape 75"/>
+          <p:cNvPr id="102" name="Shape 79"/>
           <p:cNvSpPr/>
           <p:nvPr/>
         </p:nvSpPr>
@@ -4172,7 +4338,7 @@
       </p:sp>
       <p:sp>
         <p:nvSpPr>
-          <p:cNvPr id="97" name="Shape 76"/>
+          <p:cNvPr id="103" name="Shape 80"/>
           <p:cNvSpPr/>
           <p:nvPr/>
         </p:nvSpPr>
@@ -4192,14 +4358,14 @@
       </p:sp>
       <p:pic>
         <p:nvPicPr>
-          <p:cNvPr id="98" name="Image 19" descr="preencoded.png">    </p:cNvPr>
+          <p:cNvPr id="104" name="Image 21" descr="preencoded.png">    </p:cNvPr>
           <p:cNvPicPr>
             <a:picLocks noChangeAspect="1"/>
           </p:cNvPicPr>
           <p:nvPr/>
         </p:nvPicPr>
         <p:blipFill>
-          <a:blip r:embed="rId20"/>
+          <a:blip r:embed="rId22"/>
           <a:stretch>
             <a:fillRect/>
           </a:stretch>
@@ -4216,7 +4382,7 @@
       </p:pic>
       <p:sp>
         <p:nvSpPr>
-          <p:cNvPr id="99" name="Text 77"/>
+          <p:cNvPr id="105" name="Text 81"/>
           <p:cNvSpPr txBox="1"/>
           <p:nvPr/>
         </p:nvSpPr>
@@ -4278,7 +4444,7 @@
       </p:sp>
       <p:sp>
         <p:nvSpPr>
-          <p:cNvPr id="100" name="Text 78"/>
+          <p:cNvPr id="106" name="Text 82"/>
           <p:cNvSpPr txBox="1"/>
           <p:nvPr/>
         </p:nvSpPr>
@@ -4317,7 +4483,7 @@
       </p:sp>
       <p:sp>
         <p:nvSpPr>
-          <p:cNvPr id="101" name="Text 79"/>
+          <p:cNvPr id="107" name="Text 83"/>
           <p:cNvSpPr txBox="1"/>
           <p:nvPr/>
         </p:nvSpPr>
@@ -4356,7 +4522,7 @@
       </p:sp>
       <p:sp>
         <p:nvSpPr>
-          <p:cNvPr id="102" name="Text 80"/>
+          <p:cNvPr id="108" name="Text 84"/>
           <p:cNvSpPr txBox="1"/>
           <p:nvPr/>
         </p:nvSpPr>

</xml_diff>

<commit_message>
Add Order Corrections to the data-in-transit list
Placed directly below Orders in the center hub. List grows to 9 items;
row sizing already computed dynamically from item count, so all fit
cleanly with no further layout changes needed.

Co-Authored-By: Claude Sonnet 5 <noreply@anthropic.com>
Claude-Session: https://claude.ai/code/session_01XLt1ze3JWdaihuSAsk6TrZ
</commit_message>
<xml_diff>
--- a/docs/presentations/Transfer_Agent_Data_Flow.pptx
+++ b/docs/presentations/Transfer_Agent_Data_Flow.pptx
@@ -1746,8 +1746,8 @@
         </p:nvSpPr>
         <p:spPr>
           <a:xfrm>
-            <a:off x="4361688" y="3345561"/>
-            <a:ext cx="246888" cy="246888"/>
+            <a:off x="4361688" y="3337560"/>
+            <a:ext cx="226568" cy="226568"/>
           </a:xfrm>
           <a:prstGeom prst="ellipse">
             <a:avLst/>
@@ -1774,8 +1774,8 @@
         </p:blipFill>
         <p:spPr>
           <a:xfrm>
-            <a:off x="4425879" y="3409752"/>
-            <a:ext cx="118506" cy="118506"/>
+            <a:off x="4420596" y="3396468"/>
+            <a:ext cx="108753" cy="108753"/>
           </a:xfrm>
           <a:prstGeom prst="rect">
             <a:avLst/>
@@ -1790,8 +1790,8 @@
         </p:nvSpPr>
         <p:spPr>
           <a:xfrm>
-            <a:off x="4727448" y="3319272"/>
-            <a:ext cx="1453896" cy="299466"/>
+            <a:off x="4707128" y="3319272"/>
+            <a:ext cx="1474216" cy="263144"/>
           </a:xfrm>
           <a:prstGeom prst="rect">
             <a:avLst/>
@@ -1829,8 +1829,8 @@
         </p:nvSpPr>
         <p:spPr>
           <a:xfrm>
-            <a:off x="4361688" y="3672459"/>
-            <a:ext cx="246888" cy="246888"/>
+            <a:off x="4361688" y="3628136"/>
+            <a:ext cx="226568" cy="226568"/>
           </a:xfrm>
           <a:prstGeom prst="ellipse">
             <a:avLst/>
@@ -1857,8 +1857,8 @@
         </p:blipFill>
         <p:spPr>
           <a:xfrm>
-            <a:off x="4425879" y="3736650"/>
-            <a:ext cx="118506" cy="118506"/>
+            <a:off x="4420596" y="3687044"/>
+            <a:ext cx="108753" cy="108753"/>
           </a:xfrm>
           <a:prstGeom prst="rect">
             <a:avLst/>
@@ -1873,8 +1873,91 @@
         </p:nvSpPr>
         <p:spPr>
           <a:xfrm>
-            <a:off x="4727448" y="3646170"/>
-            <a:ext cx="1453896" cy="299466"/>
+            <a:off x="4707128" y="3609848"/>
+            <a:ext cx="1474216" cy="263144"/>
+          </a:xfrm>
+          <a:prstGeom prst="rect">
+            <a:avLst/>
+          </a:prstGeom>
+          <a:noFill/>
+          <a:ln/>
+        </p:spPr>
+        <p:txBody>
+          <a:bodyPr wrap="square" lIns="0" tIns="0" rIns="0" bIns="0" rtlCol="0" anchor="ctr"/>
+          <a:lstStyle/>
+          <a:p>
+            <a:pPr algn="l" indent="0" marL="0">
+              <a:buNone/>
+            </a:pPr>
+            <a:r>
+              <a:rPr lang="en-US" sz="1050" b="1" dirty="0">
+                <a:solidFill>
+                  <a:srgbClr val="CADCFC"/>
+                </a:solidFill>
+                <a:latin typeface="Calibri" pitchFamily="34" charset="0"/>
+                <a:ea typeface="Calibri" pitchFamily="34" charset="-122"/>
+                <a:cs typeface="Calibri" pitchFamily="34" charset="-120"/>
+              </a:rPr>
+              <a:t>Order Corrections</a:t>
+            </a:r>
+            <a:endParaRPr lang="en-US" sz="1050" dirty="0"/>
+          </a:p>
+        </p:txBody>
+      </p:sp>
+      <p:sp>
+        <p:nvSpPr>
+          <p:cNvPr id="23" name="Shape 18"/>
+          <p:cNvSpPr/>
+          <p:nvPr/>
+        </p:nvSpPr>
+        <p:spPr>
+          <a:xfrm>
+            <a:off x="4361688" y="3918712"/>
+            <a:ext cx="226568" cy="226568"/>
+          </a:xfrm>
+          <a:prstGeom prst="ellipse">
+            <a:avLst/>
+          </a:prstGeom>
+          <a:solidFill>
+            <a:srgbClr val="3A4694"/>
+          </a:solidFill>
+          <a:ln/>
+        </p:spPr>
+      </p:sp>
+      <p:pic>
+        <p:nvPicPr>
+          <p:cNvPr id="24" name="Image 3" descr="preencoded.png">    </p:cNvPr>
+          <p:cNvPicPr>
+            <a:picLocks noChangeAspect="1"/>
+          </p:cNvPicPr>
+          <p:nvPr/>
+        </p:nvPicPr>
+        <p:blipFill>
+          <a:blip r:embed="rId4"/>
+          <a:stretch>
+            <a:fillRect/>
+          </a:stretch>
+        </p:blipFill>
+        <p:spPr>
+          <a:xfrm>
+            <a:off x="4420596" y="3977620"/>
+            <a:ext cx="108753" cy="108753"/>
+          </a:xfrm>
+          <a:prstGeom prst="rect">
+            <a:avLst/>
+          </a:prstGeom>
+        </p:spPr>
+      </p:pic>
+      <p:sp>
+        <p:nvSpPr>
+          <p:cNvPr id="25" name="Text 19"/>
+          <p:cNvSpPr txBox="1"/>
+          <p:nvPr/>
+        </p:nvSpPr>
+        <p:spPr>
+          <a:xfrm>
+            <a:off x="4707128" y="3900424"/>
+            <a:ext cx="1474216" cy="263144"/>
           </a:xfrm>
           <a:prstGeom prst="rect">
             <a:avLst/>
@@ -1906,14 +1989,14 @@
       </p:sp>
       <p:sp>
         <p:nvSpPr>
-          <p:cNvPr id="23" name="Shape 18"/>
-          <p:cNvSpPr/>
-          <p:nvPr/>
-        </p:nvSpPr>
-        <p:spPr>
-          <a:xfrm>
-            <a:off x="4361688" y="3999357"/>
-            <a:ext cx="246888" cy="246888"/>
+          <p:cNvPr id="26" name="Shape 20"/>
+          <p:cNvSpPr/>
+          <p:nvPr/>
+        </p:nvSpPr>
+        <p:spPr>
+          <a:xfrm>
+            <a:off x="4361688" y="4209288"/>
+            <a:ext cx="226568" cy="226568"/>
           </a:xfrm>
           <a:prstGeom prst="ellipse">
             <a:avLst/>
@@ -1926,22 +2009,22 @@
       </p:sp>
       <p:pic>
         <p:nvPicPr>
-          <p:cNvPr id="24" name="Image 3" descr="preencoded.png">    </p:cNvPr>
+          <p:cNvPr id="27" name="Image 4" descr="preencoded.png">    </p:cNvPr>
           <p:cNvPicPr>
             <a:picLocks noChangeAspect="1"/>
           </p:cNvPicPr>
           <p:nvPr/>
         </p:nvPicPr>
         <p:blipFill>
-          <a:blip r:embed="rId4"/>
+          <a:blip r:embed="rId5"/>
           <a:stretch>
             <a:fillRect/>
           </a:stretch>
         </p:blipFill>
         <p:spPr>
           <a:xfrm>
-            <a:off x="4425879" y="4063548"/>
-            <a:ext cx="118506" cy="118506"/>
+            <a:off x="4420596" y="4268196"/>
+            <a:ext cx="108753" cy="108753"/>
           </a:xfrm>
           <a:prstGeom prst="rect">
             <a:avLst/>
@@ -1950,14 +2033,14 @@
       </p:pic>
       <p:sp>
         <p:nvSpPr>
-          <p:cNvPr id="25" name="Text 19"/>
+          <p:cNvPr id="28" name="Text 21"/>
           <p:cNvSpPr txBox="1"/>
           <p:nvPr/>
         </p:nvSpPr>
         <p:spPr>
           <a:xfrm>
-            <a:off x="4727448" y="3973068"/>
-            <a:ext cx="1453896" cy="299466"/>
+            <a:off x="4707128" y="4191000"/>
+            <a:ext cx="1474216" cy="263144"/>
           </a:xfrm>
           <a:prstGeom prst="rect">
             <a:avLst/>
@@ -1989,14 +2072,14 @@
       </p:sp>
       <p:sp>
         <p:nvSpPr>
-          <p:cNvPr id="26" name="Shape 20"/>
-          <p:cNvSpPr/>
-          <p:nvPr/>
-        </p:nvSpPr>
-        <p:spPr>
-          <a:xfrm>
-            <a:off x="4361688" y="4326255"/>
-            <a:ext cx="246888" cy="246888"/>
+          <p:cNvPr id="29" name="Shape 22"/>
+          <p:cNvSpPr/>
+          <p:nvPr/>
+        </p:nvSpPr>
+        <p:spPr>
+          <a:xfrm>
+            <a:off x="4361688" y="4499864"/>
+            <a:ext cx="226568" cy="226568"/>
           </a:xfrm>
           <a:prstGeom prst="ellipse">
             <a:avLst/>
@@ -2009,22 +2092,22 @@
       </p:sp>
       <p:pic>
         <p:nvPicPr>
-          <p:cNvPr id="27" name="Image 4" descr="preencoded.png">    </p:cNvPr>
+          <p:cNvPr id="30" name="Image 5" descr="preencoded.png">    </p:cNvPr>
           <p:cNvPicPr>
             <a:picLocks noChangeAspect="1"/>
           </p:cNvPicPr>
           <p:nvPr/>
         </p:nvPicPr>
         <p:blipFill>
-          <a:blip r:embed="rId5"/>
+          <a:blip r:embed="rId6"/>
           <a:stretch>
             <a:fillRect/>
           </a:stretch>
         </p:blipFill>
         <p:spPr>
           <a:xfrm>
-            <a:off x="4425879" y="4390446"/>
-            <a:ext cx="118506" cy="118506"/>
+            <a:off x="4420596" y="4558772"/>
+            <a:ext cx="108753" cy="108753"/>
           </a:xfrm>
           <a:prstGeom prst="rect">
             <a:avLst/>
@@ -2033,14 +2116,14 @@
       </p:pic>
       <p:sp>
         <p:nvSpPr>
-          <p:cNvPr id="28" name="Text 21"/>
+          <p:cNvPr id="31" name="Text 23"/>
           <p:cNvSpPr txBox="1"/>
           <p:nvPr/>
         </p:nvSpPr>
         <p:spPr>
           <a:xfrm>
-            <a:off x="4727448" y="4299966"/>
-            <a:ext cx="1453896" cy="299466"/>
+            <a:off x="4707128" y="4481576"/>
+            <a:ext cx="1474216" cy="263144"/>
           </a:xfrm>
           <a:prstGeom prst="rect">
             <a:avLst/>
@@ -2072,14 +2155,14 @@
       </p:sp>
       <p:sp>
         <p:nvSpPr>
-          <p:cNvPr id="29" name="Shape 22"/>
-          <p:cNvSpPr/>
-          <p:nvPr/>
-        </p:nvSpPr>
-        <p:spPr>
-          <a:xfrm>
-            <a:off x="4361688" y="4653153"/>
-            <a:ext cx="246888" cy="246888"/>
+          <p:cNvPr id="32" name="Shape 24"/>
+          <p:cNvSpPr/>
+          <p:nvPr/>
+        </p:nvSpPr>
+        <p:spPr>
+          <a:xfrm>
+            <a:off x="4361688" y="4790440"/>
+            <a:ext cx="226568" cy="226568"/>
           </a:xfrm>
           <a:prstGeom prst="ellipse">
             <a:avLst/>
@@ -2092,22 +2175,22 @@
       </p:sp>
       <p:pic>
         <p:nvPicPr>
-          <p:cNvPr id="30" name="Image 5" descr="preencoded.png">    </p:cNvPr>
+          <p:cNvPr id="33" name="Image 6" descr="preencoded.png">    </p:cNvPr>
           <p:cNvPicPr>
             <a:picLocks noChangeAspect="1"/>
           </p:cNvPicPr>
           <p:nvPr/>
         </p:nvPicPr>
         <p:blipFill>
-          <a:blip r:embed="rId6"/>
+          <a:blip r:embed="rId7"/>
           <a:stretch>
             <a:fillRect/>
           </a:stretch>
         </p:blipFill>
         <p:spPr>
           <a:xfrm>
-            <a:off x="4425879" y="4717344"/>
-            <a:ext cx="118506" cy="118506"/>
+            <a:off x="4420596" y="4849348"/>
+            <a:ext cx="108753" cy="108753"/>
           </a:xfrm>
           <a:prstGeom prst="rect">
             <a:avLst/>
@@ -2116,14 +2199,14 @@
       </p:pic>
       <p:sp>
         <p:nvSpPr>
-          <p:cNvPr id="31" name="Text 23"/>
+          <p:cNvPr id="34" name="Text 25"/>
           <p:cNvSpPr txBox="1"/>
           <p:nvPr/>
         </p:nvSpPr>
         <p:spPr>
           <a:xfrm>
-            <a:off x="4727448" y="4626864"/>
-            <a:ext cx="1453896" cy="299466"/>
+            <a:off x="4707128" y="4772152"/>
+            <a:ext cx="1474216" cy="263144"/>
           </a:xfrm>
           <a:prstGeom prst="rect">
             <a:avLst/>
@@ -2155,14 +2238,14 @@
       </p:sp>
       <p:sp>
         <p:nvSpPr>
-          <p:cNvPr id="32" name="Shape 24"/>
-          <p:cNvSpPr/>
-          <p:nvPr/>
-        </p:nvSpPr>
-        <p:spPr>
-          <a:xfrm>
-            <a:off x="4361688" y="4980051"/>
-            <a:ext cx="246888" cy="246888"/>
+          <p:cNvPr id="35" name="Shape 26"/>
+          <p:cNvSpPr/>
+          <p:nvPr/>
+        </p:nvSpPr>
+        <p:spPr>
+          <a:xfrm>
+            <a:off x="4361688" y="5081016"/>
+            <a:ext cx="226568" cy="226568"/>
           </a:xfrm>
           <a:prstGeom prst="ellipse">
             <a:avLst/>
@@ -2175,22 +2258,22 @@
       </p:sp>
       <p:pic>
         <p:nvPicPr>
-          <p:cNvPr id="33" name="Image 6" descr="preencoded.png">    </p:cNvPr>
+          <p:cNvPr id="36" name="Image 7" descr="preencoded.png">    </p:cNvPr>
           <p:cNvPicPr>
             <a:picLocks noChangeAspect="1"/>
           </p:cNvPicPr>
           <p:nvPr/>
         </p:nvPicPr>
         <p:blipFill>
-          <a:blip r:embed="rId7"/>
+          <a:blip r:embed="rId8"/>
           <a:stretch>
             <a:fillRect/>
           </a:stretch>
         </p:blipFill>
         <p:spPr>
           <a:xfrm>
-            <a:off x="4425879" y="5044242"/>
-            <a:ext cx="118506" cy="118506"/>
+            <a:off x="4420596" y="5139924"/>
+            <a:ext cx="108753" cy="108753"/>
           </a:xfrm>
           <a:prstGeom prst="rect">
             <a:avLst/>
@@ -2199,14 +2282,14 @@
       </p:pic>
       <p:sp>
         <p:nvSpPr>
-          <p:cNvPr id="34" name="Text 25"/>
+          <p:cNvPr id="37" name="Text 27"/>
           <p:cNvSpPr txBox="1"/>
           <p:nvPr/>
         </p:nvSpPr>
         <p:spPr>
           <a:xfrm>
-            <a:off x="4727448" y="4953762"/>
-            <a:ext cx="1453896" cy="299466"/>
+            <a:off x="4707128" y="5062728"/>
+            <a:ext cx="1474216" cy="263144"/>
           </a:xfrm>
           <a:prstGeom prst="rect">
             <a:avLst/>
@@ -2238,14 +2321,14 @@
       </p:sp>
       <p:sp>
         <p:nvSpPr>
-          <p:cNvPr id="35" name="Shape 26"/>
-          <p:cNvSpPr/>
-          <p:nvPr/>
-        </p:nvSpPr>
-        <p:spPr>
-          <a:xfrm>
-            <a:off x="4361688" y="5306949"/>
-            <a:ext cx="246888" cy="246888"/>
+          <p:cNvPr id="38" name="Shape 28"/>
+          <p:cNvSpPr/>
+          <p:nvPr/>
+        </p:nvSpPr>
+        <p:spPr>
+          <a:xfrm>
+            <a:off x="4361688" y="5371592"/>
+            <a:ext cx="226568" cy="226568"/>
           </a:xfrm>
           <a:prstGeom prst="ellipse">
             <a:avLst/>
@@ -2258,22 +2341,22 @@
       </p:sp>
       <p:pic>
         <p:nvPicPr>
-          <p:cNvPr id="36" name="Image 7" descr="preencoded.png">    </p:cNvPr>
+          <p:cNvPr id="39" name="Image 8" descr="preencoded.png">    </p:cNvPr>
           <p:cNvPicPr>
             <a:picLocks noChangeAspect="1"/>
           </p:cNvPicPr>
           <p:nvPr/>
         </p:nvPicPr>
         <p:blipFill>
-          <a:blip r:embed="rId8"/>
+          <a:blip r:embed="rId9"/>
           <a:stretch>
             <a:fillRect/>
           </a:stretch>
         </p:blipFill>
         <p:spPr>
           <a:xfrm>
-            <a:off x="4425879" y="5371140"/>
-            <a:ext cx="118506" cy="118506"/>
+            <a:off x="4420596" y="5430500"/>
+            <a:ext cx="108753" cy="108753"/>
           </a:xfrm>
           <a:prstGeom prst="rect">
             <a:avLst/>
@@ -2282,14 +2365,14 @@
       </p:pic>
       <p:sp>
         <p:nvSpPr>
-          <p:cNvPr id="37" name="Text 27"/>
+          <p:cNvPr id="40" name="Text 29"/>
           <p:cNvSpPr txBox="1"/>
           <p:nvPr/>
         </p:nvSpPr>
         <p:spPr>
           <a:xfrm>
-            <a:off x="4727448" y="5280660"/>
-            <a:ext cx="1453896" cy="299466"/>
+            <a:off x="4707128" y="5353304"/>
+            <a:ext cx="1474216" cy="263144"/>
           </a:xfrm>
           <a:prstGeom prst="rect">
             <a:avLst/>
@@ -2321,14 +2404,14 @@
       </p:sp>
       <p:sp>
         <p:nvSpPr>
-          <p:cNvPr id="38" name="Shape 28"/>
-          <p:cNvSpPr/>
-          <p:nvPr/>
-        </p:nvSpPr>
-        <p:spPr>
-          <a:xfrm>
-            <a:off x="4361688" y="5633847"/>
-            <a:ext cx="246888" cy="246888"/>
+          <p:cNvPr id="41" name="Shape 30"/>
+          <p:cNvSpPr/>
+          <p:nvPr/>
+        </p:nvSpPr>
+        <p:spPr>
+          <a:xfrm>
+            <a:off x="4361688" y="5662168"/>
+            <a:ext cx="226568" cy="226568"/>
           </a:xfrm>
           <a:prstGeom prst="ellipse">
             <a:avLst/>
@@ -2341,22 +2424,22 @@
       </p:sp>
       <p:pic>
         <p:nvPicPr>
-          <p:cNvPr id="39" name="Image 8" descr="preencoded.png">    </p:cNvPr>
+          <p:cNvPr id="42" name="Image 9" descr="preencoded.png">    </p:cNvPr>
           <p:cNvPicPr>
             <a:picLocks noChangeAspect="1"/>
           </p:cNvPicPr>
           <p:nvPr/>
         </p:nvPicPr>
         <p:blipFill>
-          <a:blip r:embed="rId9"/>
+          <a:blip r:embed="rId10"/>
           <a:stretch>
             <a:fillRect/>
           </a:stretch>
         </p:blipFill>
         <p:spPr>
           <a:xfrm>
-            <a:off x="4425879" y="5698038"/>
-            <a:ext cx="118506" cy="118506"/>
+            <a:off x="4420596" y="5721076"/>
+            <a:ext cx="108753" cy="108753"/>
           </a:xfrm>
           <a:prstGeom prst="rect">
             <a:avLst/>
@@ -2365,14 +2448,14 @@
       </p:pic>
       <p:sp>
         <p:nvSpPr>
-          <p:cNvPr id="40" name="Text 29"/>
+          <p:cNvPr id="43" name="Text 31"/>
           <p:cNvSpPr txBox="1"/>
           <p:nvPr/>
         </p:nvSpPr>
         <p:spPr>
           <a:xfrm>
-            <a:off x="4727448" y="5607558"/>
-            <a:ext cx="1453896" cy="299466"/>
+            <a:off x="4707128" y="5643880"/>
+            <a:ext cx="1474216" cy="263144"/>
           </a:xfrm>
           <a:prstGeom prst="rect">
             <a:avLst/>
@@ -2404,7 +2487,7 @@
       </p:sp>
       <p:sp>
         <p:nvSpPr>
-          <p:cNvPr id="41" name="Shape 30"/>
+          <p:cNvPr id="44" name="Shape 32"/>
           <p:cNvSpPr/>
           <p:nvPr/>
         </p:nvSpPr>
@@ -2429,7 +2512,7 @@
       </p:sp>
       <p:sp>
         <p:nvSpPr>
-          <p:cNvPr id="42" name="Shape 31"/>
+          <p:cNvPr id="45" name="Shape 33"/>
           <p:cNvSpPr/>
           <p:nvPr/>
         </p:nvSpPr>
@@ -2454,7 +2537,7 @@
       </p:sp>
       <p:sp>
         <p:nvSpPr>
-          <p:cNvPr id="43" name="Shape 32"/>
+          <p:cNvPr id="46" name="Shape 34"/>
           <p:cNvSpPr/>
           <p:nvPr/>
         </p:nvSpPr>
@@ -2479,7 +2562,7 @@
       </p:sp>
       <p:sp>
         <p:nvSpPr>
-          <p:cNvPr id="44" name="Shape 33"/>
+          <p:cNvPr id="47" name="Shape 35"/>
           <p:cNvSpPr/>
           <p:nvPr/>
         </p:nvSpPr>
@@ -2504,7 +2587,7 @@
       </p:sp>
       <p:sp>
         <p:nvSpPr>
-          <p:cNvPr id="45" name="Shape 34"/>
+          <p:cNvPr id="48" name="Shape 36"/>
           <p:cNvSpPr/>
           <p:nvPr/>
         </p:nvSpPr>
@@ -2529,7 +2612,7 @@
       </p:sp>
       <p:sp>
         <p:nvSpPr>
-          <p:cNvPr id="46" name="Shape 35"/>
+          <p:cNvPr id="49" name="Shape 37"/>
           <p:cNvSpPr/>
           <p:nvPr/>
         </p:nvSpPr>
@@ -2553,7 +2636,7 @@
       </p:sp>
       <p:sp>
         <p:nvSpPr>
-          <p:cNvPr id="47" name="Shape 36"/>
+          <p:cNvPr id="50" name="Shape 38"/>
           <p:cNvSpPr/>
           <p:nvPr/>
         </p:nvSpPr>
@@ -2578,7 +2661,7 @@
       </p:sp>
       <p:sp>
         <p:nvSpPr>
-          <p:cNvPr id="48" name="Shape 37"/>
+          <p:cNvPr id="51" name="Shape 39"/>
           <p:cNvSpPr/>
           <p:nvPr/>
         </p:nvSpPr>
@@ -2603,7 +2686,7 @@
       </p:sp>
       <p:sp>
         <p:nvSpPr>
-          <p:cNvPr id="49" name="Shape 38"/>
+          <p:cNvPr id="52" name="Shape 40"/>
           <p:cNvSpPr/>
           <p:nvPr/>
         </p:nvSpPr>
@@ -2627,7 +2710,7 @@
       </p:sp>
       <p:sp>
         <p:nvSpPr>
-          <p:cNvPr id="50" name="Shape 39"/>
+          <p:cNvPr id="53" name="Shape 41"/>
           <p:cNvSpPr/>
           <p:nvPr/>
         </p:nvSpPr>
@@ -2651,7 +2734,7 @@
       </p:sp>
       <p:sp>
         <p:nvSpPr>
-          <p:cNvPr id="51" name="Shape 40"/>
+          <p:cNvPr id="54" name="Shape 42"/>
           <p:cNvSpPr/>
           <p:nvPr/>
         </p:nvSpPr>
@@ -2676,7 +2759,7 @@
       </p:sp>
       <p:sp>
         <p:nvSpPr>
-          <p:cNvPr id="52" name="Shape 41"/>
+          <p:cNvPr id="55" name="Shape 43"/>
           <p:cNvSpPr/>
           <p:nvPr/>
         </p:nvSpPr>
@@ -2700,7 +2783,7 @@
       </p:sp>
       <p:sp>
         <p:nvSpPr>
-          <p:cNvPr id="53" name="Shape 42"/>
+          <p:cNvPr id="56" name="Shape 44"/>
           <p:cNvSpPr/>
           <p:nvPr/>
         </p:nvSpPr>
@@ -2724,7 +2807,7 @@
       </p:sp>
       <p:sp>
         <p:nvSpPr>
-          <p:cNvPr id="54" name="Shape 43"/>
+          <p:cNvPr id="57" name="Shape 45"/>
           <p:cNvSpPr/>
           <p:nvPr/>
         </p:nvSpPr>
@@ -2758,7 +2841,7 @@
       </p:sp>
       <p:sp>
         <p:nvSpPr>
-          <p:cNvPr id="55" name="Shape 44"/>
+          <p:cNvPr id="58" name="Shape 46"/>
           <p:cNvSpPr/>
           <p:nvPr/>
         </p:nvSpPr>
@@ -2778,14 +2861,14 @@
       </p:sp>
       <p:pic>
         <p:nvPicPr>
-          <p:cNvPr id="56" name="Image 9" descr="preencoded.png">    </p:cNvPr>
+          <p:cNvPr id="59" name="Image 10" descr="preencoded.png">    </p:cNvPr>
           <p:cNvPicPr>
             <a:picLocks noChangeAspect="1"/>
           </p:cNvPicPr>
           <p:nvPr/>
         </p:nvPicPr>
         <p:blipFill>
-          <a:blip r:embed="rId10"/>
+          <a:blip r:embed="rId11"/>
           <a:stretch>
             <a:fillRect/>
           </a:stretch>
@@ -2802,7 +2885,7 @@
       </p:pic>
       <p:sp>
         <p:nvSpPr>
-          <p:cNvPr id="57" name="Text 45"/>
+          <p:cNvPr id="60" name="Text 47"/>
           <p:cNvSpPr txBox="1"/>
           <p:nvPr/>
         </p:nvSpPr>
@@ -2864,7 +2947,7 @@
       </p:sp>
       <p:sp>
         <p:nvSpPr>
-          <p:cNvPr id="58" name="Shape 46"/>
+          <p:cNvPr id="61" name="Shape 48"/>
           <p:cNvSpPr/>
           <p:nvPr/>
         </p:nvSpPr>
@@ -2898,7 +2981,7 @@
       </p:sp>
       <p:sp>
         <p:nvSpPr>
-          <p:cNvPr id="59" name="Shape 47"/>
+          <p:cNvPr id="62" name="Shape 49"/>
           <p:cNvSpPr/>
           <p:nvPr/>
         </p:nvSpPr>
@@ -2918,14 +3001,14 @@
       </p:sp>
       <p:pic>
         <p:nvPicPr>
-          <p:cNvPr id="60" name="Image 10" descr="preencoded.png">    </p:cNvPr>
+          <p:cNvPr id="63" name="Image 11" descr="preencoded.png">    </p:cNvPr>
           <p:cNvPicPr>
             <a:picLocks noChangeAspect="1"/>
           </p:cNvPicPr>
           <p:nvPr/>
         </p:nvPicPr>
         <p:blipFill>
-          <a:blip r:embed="rId11"/>
+          <a:blip r:embed="rId12"/>
           <a:stretch>
             <a:fillRect/>
           </a:stretch>
@@ -2942,7 +3025,7 @@
       </p:pic>
       <p:sp>
         <p:nvSpPr>
-          <p:cNvPr id="61" name="Text 48"/>
+          <p:cNvPr id="64" name="Text 50"/>
           <p:cNvSpPr txBox="1"/>
           <p:nvPr/>
         </p:nvSpPr>
@@ -3004,7 +3087,7 @@
       </p:sp>
       <p:sp>
         <p:nvSpPr>
-          <p:cNvPr id="62" name="Shape 49"/>
+          <p:cNvPr id="65" name="Shape 51"/>
           <p:cNvSpPr/>
           <p:nvPr/>
         </p:nvSpPr>
@@ -3038,7 +3121,7 @@
       </p:sp>
       <p:sp>
         <p:nvSpPr>
-          <p:cNvPr id="63" name="Shape 50"/>
+          <p:cNvPr id="66" name="Shape 52"/>
           <p:cNvSpPr/>
           <p:nvPr/>
         </p:nvSpPr>
@@ -3058,14 +3141,14 @@
       </p:sp>
       <p:pic>
         <p:nvPicPr>
-          <p:cNvPr id="64" name="Image 11" descr="preencoded.png">    </p:cNvPr>
+          <p:cNvPr id="67" name="Image 12" descr="preencoded.png">    </p:cNvPr>
           <p:cNvPicPr>
             <a:picLocks noChangeAspect="1"/>
           </p:cNvPicPr>
           <p:nvPr/>
         </p:nvPicPr>
         <p:blipFill>
-          <a:blip r:embed="rId12"/>
+          <a:blip r:embed="rId13"/>
           <a:stretch>
             <a:fillRect/>
           </a:stretch>
@@ -3082,7 +3165,7 @@
       </p:pic>
       <p:sp>
         <p:nvSpPr>
-          <p:cNvPr id="65" name="Text 51"/>
+          <p:cNvPr id="68" name="Text 53"/>
           <p:cNvSpPr txBox="1"/>
           <p:nvPr/>
         </p:nvSpPr>
@@ -3144,7 +3227,7 @@
       </p:sp>
       <p:sp>
         <p:nvSpPr>
-          <p:cNvPr id="66" name="Shape 52"/>
+          <p:cNvPr id="69" name="Shape 54"/>
           <p:cNvSpPr/>
           <p:nvPr/>
         </p:nvSpPr>
@@ -3178,7 +3261,7 @@
       </p:sp>
       <p:sp>
         <p:nvSpPr>
-          <p:cNvPr id="67" name="Shape 53"/>
+          <p:cNvPr id="70" name="Shape 55"/>
           <p:cNvSpPr/>
           <p:nvPr/>
         </p:nvSpPr>
@@ -3198,14 +3281,14 @@
       </p:sp>
       <p:pic>
         <p:nvPicPr>
-          <p:cNvPr id="68" name="Image 12" descr="preencoded.png">    </p:cNvPr>
+          <p:cNvPr id="71" name="Image 13" descr="preencoded.png">    </p:cNvPr>
           <p:cNvPicPr>
             <a:picLocks noChangeAspect="1"/>
           </p:cNvPicPr>
           <p:nvPr/>
         </p:nvPicPr>
         <p:blipFill>
-          <a:blip r:embed="rId13"/>
+          <a:blip r:embed="rId14"/>
           <a:stretch>
             <a:fillRect/>
           </a:stretch>
@@ -3222,7 +3305,7 @@
       </p:pic>
       <p:sp>
         <p:nvSpPr>
-          <p:cNvPr id="69" name="Text 54"/>
+          <p:cNvPr id="72" name="Text 56"/>
           <p:cNvSpPr txBox="1"/>
           <p:nvPr/>
         </p:nvSpPr>
@@ -3284,7 +3367,7 @@
       </p:sp>
       <p:sp>
         <p:nvSpPr>
-          <p:cNvPr id="70" name="Shape 55"/>
+          <p:cNvPr id="73" name="Shape 57"/>
           <p:cNvSpPr/>
           <p:nvPr/>
         </p:nvSpPr>
@@ -3318,7 +3401,7 @@
       </p:sp>
       <p:sp>
         <p:nvSpPr>
-          <p:cNvPr id="71" name="Shape 56"/>
+          <p:cNvPr id="74" name="Shape 58"/>
           <p:cNvSpPr/>
           <p:nvPr/>
         </p:nvSpPr>
@@ -3338,14 +3421,14 @@
       </p:sp>
       <p:pic>
         <p:nvPicPr>
-          <p:cNvPr id="72" name="Image 13" descr="preencoded.png">    </p:cNvPr>
+          <p:cNvPr id="75" name="Image 14" descr="preencoded.png">    </p:cNvPr>
           <p:cNvPicPr>
             <a:picLocks noChangeAspect="1"/>
           </p:cNvPicPr>
           <p:nvPr/>
         </p:nvPicPr>
         <p:blipFill>
-          <a:blip r:embed="rId14"/>
+          <a:blip r:embed="rId15"/>
           <a:stretch>
             <a:fillRect/>
           </a:stretch>
@@ -3362,7 +3445,7 @@
       </p:pic>
       <p:sp>
         <p:nvSpPr>
-          <p:cNvPr id="73" name="Text 57"/>
+          <p:cNvPr id="76" name="Text 59"/>
           <p:cNvSpPr txBox="1"/>
           <p:nvPr/>
         </p:nvSpPr>
@@ -3404,7 +3487,7 @@
       </p:sp>
       <p:sp>
         <p:nvSpPr>
-          <p:cNvPr id="74" name="Shape 58"/>
+          <p:cNvPr id="77" name="Shape 60"/>
           <p:cNvSpPr/>
           <p:nvPr/>
         </p:nvSpPr>
@@ -3438,7 +3521,7 @@
       </p:sp>
       <p:sp>
         <p:nvSpPr>
-          <p:cNvPr id="75" name="Shape 59"/>
+          <p:cNvPr id="78" name="Shape 61"/>
           <p:cNvSpPr/>
           <p:nvPr/>
         </p:nvSpPr>
@@ -3458,14 +3541,14 @@
       </p:sp>
       <p:pic>
         <p:nvPicPr>
-          <p:cNvPr id="76" name="Image 14" descr="preencoded.png">    </p:cNvPr>
+          <p:cNvPr id="79" name="Image 15" descr="preencoded.png">    </p:cNvPr>
           <p:cNvPicPr>
             <a:picLocks noChangeAspect="1"/>
           </p:cNvPicPr>
           <p:nvPr/>
         </p:nvPicPr>
         <p:blipFill>
-          <a:blip r:embed="rId15"/>
+          <a:blip r:embed="rId16"/>
           <a:stretch>
             <a:fillRect/>
           </a:stretch>
@@ -3482,7 +3565,7 @@
       </p:pic>
       <p:sp>
         <p:nvSpPr>
-          <p:cNvPr id="77" name="Text 60"/>
+          <p:cNvPr id="80" name="Text 62"/>
           <p:cNvSpPr txBox="1"/>
           <p:nvPr/>
         </p:nvSpPr>
@@ -3544,7 +3627,7 @@
       </p:sp>
       <p:sp>
         <p:nvSpPr>
-          <p:cNvPr id="78" name="Shape 61"/>
+          <p:cNvPr id="81" name="Shape 63"/>
           <p:cNvSpPr/>
           <p:nvPr/>
         </p:nvSpPr>
@@ -3578,7 +3661,7 @@
       </p:sp>
       <p:sp>
         <p:nvSpPr>
-          <p:cNvPr id="79" name="Shape 62"/>
+          <p:cNvPr id="82" name="Shape 64"/>
           <p:cNvSpPr/>
           <p:nvPr/>
         </p:nvSpPr>
@@ -3598,14 +3681,14 @@
       </p:sp>
       <p:pic>
         <p:nvPicPr>
-          <p:cNvPr id="80" name="Image 15" descr="preencoded.png">    </p:cNvPr>
+          <p:cNvPr id="83" name="Image 16" descr="preencoded.png">    </p:cNvPr>
           <p:cNvPicPr>
             <a:picLocks noChangeAspect="1"/>
           </p:cNvPicPr>
           <p:nvPr/>
         </p:nvPicPr>
         <p:blipFill>
-          <a:blip r:embed="rId16"/>
+          <a:blip r:embed="rId17"/>
           <a:stretch>
             <a:fillRect/>
           </a:stretch>
@@ -3622,7 +3705,7 @@
       </p:pic>
       <p:sp>
         <p:nvSpPr>
-          <p:cNvPr id="81" name="Text 63"/>
+          <p:cNvPr id="84" name="Text 65"/>
           <p:cNvSpPr txBox="1"/>
           <p:nvPr/>
         </p:nvSpPr>
@@ -3664,7 +3747,7 @@
       </p:sp>
       <p:sp>
         <p:nvSpPr>
-          <p:cNvPr id="82" name="Shape 64"/>
+          <p:cNvPr id="85" name="Shape 66"/>
           <p:cNvSpPr/>
           <p:nvPr/>
         </p:nvSpPr>
@@ -3698,7 +3781,7 @@
       </p:sp>
       <p:sp>
         <p:nvSpPr>
-          <p:cNvPr id="83" name="Shape 65"/>
+          <p:cNvPr id="86" name="Shape 67"/>
           <p:cNvSpPr/>
           <p:nvPr/>
         </p:nvSpPr>
@@ -3718,14 +3801,14 @@
       </p:sp>
       <p:pic>
         <p:nvPicPr>
-          <p:cNvPr id="84" name="Image 16" descr="preencoded.png">    </p:cNvPr>
+          <p:cNvPr id="87" name="Image 17" descr="preencoded.png">    </p:cNvPr>
           <p:cNvPicPr>
             <a:picLocks noChangeAspect="1"/>
           </p:cNvPicPr>
           <p:nvPr/>
         </p:nvPicPr>
         <p:blipFill>
-          <a:blip r:embed="rId17"/>
+          <a:blip r:embed="rId18"/>
           <a:stretch>
             <a:fillRect/>
           </a:stretch>
@@ -3742,7 +3825,7 @@
       </p:pic>
       <p:sp>
         <p:nvSpPr>
-          <p:cNvPr id="85" name="Text 66"/>
+          <p:cNvPr id="88" name="Text 68"/>
           <p:cNvSpPr txBox="1"/>
           <p:nvPr/>
         </p:nvSpPr>
@@ -3784,7 +3867,7 @@
       </p:sp>
       <p:sp>
         <p:nvSpPr>
-          <p:cNvPr id="86" name="Shape 67"/>
+          <p:cNvPr id="89" name="Shape 69"/>
           <p:cNvSpPr/>
           <p:nvPr/>
         </p:nvSpPr>
@@ -3818,7 +3901,7 @@
       </p:sp>
       <p:sp>
         <p:nvSpPr>
-          <p:cNvPr id="87" name="Shape 68"/>
+          <p:cNvPr id="90" name="Shape 70"/>
           <p:cNvSpPr/>
           <p:nvPr/>
         </p:nvSpPr>
@@ -3838,14 +3921,14 @@
       </p:sp>
       <p:pic>
         <p:nvPicPr>
-          <p:cNvPr id="88" name="Image 17" descr="preencoded.png">    </p:cNvPr>
+          <p:cNvPr id="91" name="Image 18" descr="preencoded.png">    </p:cNvPr>
           <p:cNvPicPr>
             <a:picLocks noChangeAspect="1"/>
           </p:cNvPicPr>
           <p:nvPr/>
         </p:nvPicPr>
         <p:blipFill>
-          <a:blip r:embed="rId18"/>
+          <a:blip r:embed="rId19"/>
           <a:stretch>
             <a:fillRect/>
           </a:stretch>
@@ -3862,7 +3945,7 @@
       </p:pic>
       <p:sp>
         <p:nvSpPr>
-          <p:cNvPr id="89" name="Text 69"/>
+          <p:cNvPr id="92" name="Text 71"/>
           <p:cNvSpPr txBox="1"/>
           <p:nvPr/>
         </p:nvSpPr>
@@ -3904,7 +3987,7 @@
       </p:sp>
       <p:sp>
         <p:nvSpPr>
-          <p:cNvPr id="90" name="Shape 70"/>
+          <p:cNvPr id="93" name="Shape 72"/>
           <p:cNvSpPr/>
           <p:nvPr/>
         </p:nvSpPr>
@@ -3938,7 +4021,7 @@
       </p:sp>
       <p:sp>
         <p:nvSpPr>
-          <p:cNvPr id="91" name="Shape 71"/>
+          <p:cNvPr id="94" name="Shape 73"/>
           <p:cNvSpPr/>
           <p:nvPr/>
         </p:nvSpPr>
@@ -3958,14 +4041,14 @@
       </p:sp>
       <p:pic>
         <p:nvPicPr>
-          <p:cNvPr id="92" name="Image 18" descr="preencoded.png">    </p:cNvPr>
+          <p:cNvPr id="95" name="Image 19" descr="preencoded.png">    </p:cNvPr>
           <p:cNvPicPr>
             <a:picLocks noChangeAspect="1"/>
           </p:cNvPicPr>
           <p:nvPr/>
         </p:nvPicPr>
         <p:blipFill>
-          <a:blip r:embed="rId19"/>
+          <a:blip r:embed="rId20"/>
           <a:stretch>
             <a:fillRect/>
           </a:stretch>
@@ -3982,7 +4065,7 @@
       </p:pic>
       <p:sp>
         <p:nvSpPr>
-          <p:cNvPr id="93" name="Text 72"/>
+          <p:cNvPr id="96" name="Text 74"/>
           <p:cNvSpPr txBox="1"/>
           <p:nvPr/>
         </p:nvSpPr>
@@ -4024,7 +4107,7 @@
       </p:sp>
       <p:sp>
         <p:nvSpPr>
-          <p:cNvPr id="94" name="Shape 73"/>
+          <p:cNvPr id="97" name="Shape 75"/>
           <p:cNvSpPr/>
           <p:nvPr/>
         </p:nvSpPr>
@@ -4058,7 +4141,7 @@
       </p:sp>
       <p:sp>
         <p:nvSpPr>
-          <p:cNvPr id="95" name="Shape 74"/>
+          <p:cNvPr id="98" name="Shape 76"/>
           <p:cNvSpPr/>
           <p:nvPr/>
         </p:nvSpPr>
@@ -4078,14 +4161,14 @@
       </p:sp>
       <p:pic>
         <p:nvPicPr>
-          <p:cNvPr id="96" name="Image 19" descr="preencoded.png">    </p:cNvPr>
+          <p:cNvPr id="99" name="Image 20" descr="preencoded.png">    </p:cNvPr>
           <p:cNvPicPr>
             <a:picLocks noChangeAspect="1"/>
           </p:cNvPicPr>
           <p:nvPr/>
         </p:nvPicPr>
         <p:blipFill>
-          <a:blip r:embed="rId20"/>
+          <a:blip r:embed="rId21"/>
           <a:stretch>
             <a:fillRect/>
           </a:stretch>
@@ -4102,7 +4185,7 @@
       </p:pic>
       <p:sp>
         <p:nvSpPr>
-          <p:cNvPr id="97" name="Text 75"/>
+          <p:cNvPr id="100" name="Text 77"/>
           <p:cNvSpPr txBox="1"/>
           <p:nvPr/>
         </p:nvSpPr>
@@ -4164,7 +4247,7 @@
       </p:sp>
       <p:sp>
         <p:nvSpPr>
-          <p:cNvPr id="98" name="Shape 76"/>
+          <p:cNvPr id="101" name="Shape 78"/>
           <p:cNvSpPr/>
           <p:nvPr/>
         </p:nvSpPr>
@@ -4198,7 +4281,7 @@
       </p:sp>
       <p:sp>
         <p:nvSpPr>
-          <p:cNvPr id="99" name="Shape 77"/>
+          <p:cNvPr id="102" name="Shape 79"/>
           <p:cNvSpPr/>
           <p:nvPr/>
         </p:nvSpPr>
@@ -4218,14 +4301,14 @@
       </p:sp>
       <p:pic>
         <p:nvPicPr>
-          <p:cNvPr id="100" name="Image 20" descr="preencoded.png">    </p:cNvPr>
+          <p:cNvPr id="103" name="Image 21" descr="preencoded.png">    </p:cNvPr>
           <p:cNvPicPr>
             <a:picLocks noChangeAspect="1"/>
           </p:cNvPicPr>
           <p:nvPr/>
         </p:nvPicPr>
         <p:blipFill>
-          <a:blip r:embed="rId21"/>
+          <a:blip r:embed="rId22"/>
           <a:stretch>
             <a:fillRect/>
           </a:stretch>
@@ -4242,7 +4325,7 @@
       </p:pic>
       <p:sp>
         <p:nvSpPr>
-          <p:cNvPr id="101" name="Text 78"/>
+          <p:cNvPr id="104" name="Text 80"/>
           <p:cNvSpPr txBox="1"/>
           <p:nvPr/>
         </p:nvSpPr>
@@ -4304,7 +4387,7 @@
       </p:sp>
       <p:sp>
         <p:nvSpPr>
-          <p:cNvPr id="102" name="Shape 79"/>
+          <p:cNvPr id="105" name="Shape 81"/>
           <p:cNvSpPr/>
           <p:nvPr/>
         </p:nvSpPr>
@@ -4338,7 +4421,7 @@
       </p:sp>
       <p:sp>
         <p:nvSpPr>
-          <p:cNvPr id="103" name="Shape 80"/>
+          <p:cNvPr id="106" name="Shape 82"/>
           <p:cNvSpPr/>
           <p:nvPr/>
         </p:nvSpPr>
@@ -4358,14 +4441,14 @@
       </p:sp>
       <p:pic>
         <p:nvPicPr>
-          <p:cNvPr id="104" name="Image 21" descr="preencoded.png">    </p:cNvPr>
+          <p:cNvPr id="107" name="Image 22" descr="preencoded.png">    </p:cNvPr>
           <p:cNvPicPr>
             <a:picLocks noChangeAspect="1"/>
           </p:cNvPicPr>
           <p:nvPr/>
         </p:nvPicPr>
         <p:blipFill>
-          <a:blip r:embed="rId22"/>
+          <a:blip r:embed="rId23"/>
           <a:stretch>
             <a:fillRect/>
           </a:stretch>
@@ -4382,7 +4465,7 @@
       </p:pic>
       <p:sp>
         <p:nvSpPr>
-          <p:cNvPr id="105" name="Text 81"/>
+          <p:cNvPr id="108" name="Text 83"/>
           <p:cNvSpPr txBox="1"/>
           <p:nvPr/>
         </p:nvSpPr>
@@ -4444,7 +4527,7 @@
       </p:sp>
       <p:sp>
         <p:nvSpPr>
-          <p:cNvPr id="106" name="Text 82"/>
+          <p:cNvPr id="109" name="Text 84"/>
           <p:cNvSpPr txBox="1"/>
           <p:nvPr/>
         </p:nvSpPr>
@@ -4483,7 +4566,7 @@
       </p:sp>
       <p:sp>
         <p:nvSpPr>
-          <p:cNvPr id="107" name="Text 83"/>
+          <p:cNvPr id="110" name="Text 85"/>
           <p:cNvSpPr txBox="1"/>
           <p:nvPr/>
         </p:nvSpPr>
@@ -4522,7 +4605,7 @@
       </p:sp>
       <p:sp>
         <p:nvSpPr>
-          <p:cNvPr id="108" name="Text 84"/>
+          <p:cNvPr id="111" name="Text 86"/>
           <p:cNvSpPr txBox="1"/>
           <p:nvPr/>
         </p:nvSpPr>

</xml_diff>

<commit_message>
Swap Cash for Payments in slot 3, add Reconciliation
Data-in-transit list updated per request: removed Cash, moved Payments
into the third position (right after Order Corrections), and added
Reconciliation as a new item at the end. List order is now: Orders,
Order Corrections, Payments, Customer Info, Tax Info, Dividends,
Holdings, Fund Billing, Reconciliation.

Co-Authored-By: Claude Sonnet 5 <noreply@anthropic.com>
Claude-Session: https://claude.ai/code/session_01XLt1ze3JWdaihuSAsk6TrZ
</commit_message>
<xml_diff>
--- a/docs/presentations/Transfer_Agent_Data_Flow.pptx
+++ b/docs/presentations/Transfer_Agent_Data_Flow.pptx
@@ -1981,7 +1981,7 @@
                 <a:ea typeface="Calibri" pitchFamily="34" charset="-122"/>
                 <a:cs typeface="Calibri" pitchFamily="34" charset="-120"/>
               </a:rPr>
-              <a:t>Cash</a:t>
+              <a:t>Payments</a:t>
             </a:r>
             <a:endParaRPr lang="en-US" sz="1050" dirty="0"/>
           </a:p>
@@ -2396,7 +2396,7 @@
                 <a:ea typeface="Calibri" pitchFamily="34" charset="-122"/>
                 <a:cs typeface="Calibri" pitchFamily="34" charset="-120"/>
               </a:rPr>
-              <a:t>Payments</a:t>
+              <a:t>Fund Billing</a:t>
             </a:r>
             <a:endParaRPr lang="en-US" sz="1050" dirty="0"/>
           </a:p>
@@ -2479,7 +2479,7 @@
                 <a:ea typeface="Calibri" pitchFamily="34" charset="-122"/>
                 <a:cs typeface="Calibri" pitchFamily="34" charset="-120"/>
               </a:rPr>
-              <a:t>Fund Billing</a:t>
+              <a:t>Reconciliation</a:t>
             </a:r>
             <a:endParaRPr lang="en-US" sz="1050" dirty="0"/>
           </a:p>

</xml_diff>